<commit_message>
Add ZeRO-1 baseline, finalize comparison plots and presentation
- Adds ZeRO-1 reference run (effective batch 32, full epoch).
- Refreshes comparison plots and method summary CSV with TP and ZeRO-1.
- Tightens the presentation: condenses bullet text, fixes title/subtitle wrapping on chart slides, rebalances section attribution (Pipeline / ZeRO-1+ZeRO-2+ZeRO-3 / FSDP+TP).
- Removes obsolete project notes file.
</commit_message>
<xml_diff>
--- a/presentation/ML710_LLaVA_Parallelism.pptx
+++ b/presentation/ML710_LLaVA_Parallelism.pptx
@@ -3244,7 +3244,7 @@
                   <a:srgbClr val="101010"/>
                 </a:solidFill>
               </a:rPr>
-              <a:t>How we built it (Ghallab)</a:t>
+              <a:t>Finding a split that fits</a:t>
             </a:r>
           </a:p>
         </p:txBody>
@@ -3282,7 +3282,22 @@
                   <a:srgbClr val="101010"/>
                 </a:solidFill>
               </a:rPr>
-              <a:t>•  Manual two-stage pipeline. We didn't use torchgpipe or DeepSpeed-Pipeline.</a:t>
+              <a:t>•  Picking the layer index k matters more than expected.</a:t>
+            </a:r>
+          </a:p>
+          <a:p>
+            <a:pPr>
+              <a:spcAft>
+                <a:spcPts val="800"/>
+              </a:spcAft>
+            </a:pPr>
+            <a:r>
+              <a:rPr sz="2200">
+                <a:solidFill>
+                  <a:srgbClr val="101010"/>
+                </a:solidFill>
+              </a:rPr>
+              <a:t>•  k = 16 (50/50 by layer count): rank 0 OOMs in the first forward.</a:t>
             </a:r>
           </a:p>
           <a:p>
@@ -3297,7 +3312,22 @@
                   <a:srgbClr val="555555"/>
                 </a:solidFill>
               </a:rPr>
-              <a:t>    –  Custom training loop: LLaVA/llava/train/train_pipe_dist.py (~520 lines).</a:t>
+              <a:t>    –  Vision tower + image features sit on rank 0. With layers 0..15 it hits 31.4 GiB — over the 32 GiB card.</a:t>
+            </a:r>
+          </a:p>
+          <a:p>
+            <a:pPr>
+              <a:spcAft>
+                <a:spcPts val="800"/>
+              </a:spcAft>
+            </a:pPr>
+            <a:r>
+              <a:rPr sz="2200">
+                <a:solidFill>
+                  <a:srgbClr val="101010"/>
+                </a:solidFill>
+              </a:rPr>
+              <a:t>•  k = 8 (push work to rank 1): rank 1 OOMs.</a:t>
             </a:r>
           </a:p>
           <a:p>
@@ -3312,7 +3342,7 @@
                   <a:srgbClr val="555555"/>
                 </a:solidFill>
               </a:rPr>
-              <a:t>    –  Gloo backend for cross-node send/recv. NCCL had ordering issues with our mixed-dtype activations.</a:t>
+              <a:t>    –  LM head + final norm + layers 8..31 hit 31.0 GiB.</a:t>
             </a:r>
           </a:p>
           <a:p>
@@ -3327,7 +3357,7 @@
                   <a:srgbClr val="101010"/>
                 </a:solidFill>
               </a:rPr>
-              <a:t>•  The model is cut at decoder layer k. There are 32 decoder layers in Vicuna-7B.</a:t>
+              <a:t>•  k = 12 with microbatch 1 + grad accum 16: both ranks fit.</a:t>
             </a:r>
           </a:p>
           <a:p>
@@ -3342,37 +3372,7 @@
                   <a:srgbClr val="555555"/>
                 </a:solidFill>
               </a:rPr>
-              <a:t>    –  Rank 0 holds the vision tower (frozen), the MLP projection, and decoder layers 0..k-1.</a:t>
-            </a:r>
-          </a:p>
-          <a:p>
-            <a:pPr lvl="1">
-              <a:spcAft>
-                <a:spcPts val="400"/>
-              </a:spcAft>
-            </a:pPr>
-            <a:r>
-              <a:rPr sz="1900">
-                <a:solidFill>
-                  <a:srgbClr val="555555"/>
-                </a:solidFill>
-              </a:rPr>
-              <a:t>    –  Rank 1 holds layers k..31, the final norm, the LM head, and computes loss.</a:t>
-            </a:r>
-          </a:p>
-          <a:p>
-            <a:pPr lvl="1">
-              <a:spcAft>
-                <a:spcPts val="400"/>
-              </a:spcAft>
-            </a:pPr>
-            <a:r>
-              <a:rPr sz="1900">
-                <a:solidFill>
-                  <a:srgbClr val="555555"/>
-                </a:solidFill>
-              </a:rPr>
-              <a:t>    –  Activations flow forward, gradients flow back, by hand.</a:t>
+              <a:t>    –  Rank 1 ≈ 31.4 GiB, rank 0 ≈ 28 GiB. Run completes 625/625 steps.</a:t>
             </a:r>
           </a:p>
           <a:p>
@@ -3387,7 +3387,7 @@
                   <a:srgbClr val="101010"/>
                 </a:solidFill>
               </a:rPr>
-              <a:t>•  Gradient accumulation 16, microbatch 1 → effective batch 16. LoRA is added on each rank's local layers.</a:t>
+              <a:t>•  Lesson: layer count is a poor proxy for memory cost. The vision tower and LM head are heavier than they look.</a:t>
             </a:r>
           </a:p>
         </p:txBody>
@@ -3439,7 +3439,7 @@
                   <a:srgbClr val="101010"/>
                 </a:solidFill>
               </a:rPr>
-              <a:t>Finding a split that fits</a:t>
+              <a:t>Pipeline — results</a:t>
             </a:r>
           </a:p>
         </p:txBody>
@@ -3453,7 +3453,7 @@
         <p:spPr>
           <a:xfrm>
             <a:off x="548640" y="1371600"/>
-            <a:ext cx="11064240" cy="5120640"/>
+            <a:ext cx="5852160" cy="5120640"/>
           </a:xfrm>
           <a:prstGeom prst="rect">
             <a:avLst/>
@@ -3472,27 +3472,72 @@
               </a:spcAft>
             </a:pPr>
             <a:r>
-              <a:rPr sz="2200">
-                <a:solidFill>
-                  <a:srgbClr val="101010"/>
-                </a:solidFill>
-              </a:rPr>
-              <a:t>•  Picking the layer index k matters more than expected.</a:t>
-            </a:r>
-          </a:p>
-          <a:p>
-            <a:pPr>
-              <a:spcAft>
-                <a:spcPts val="800"/>
-              </a:spcAft>
-            </a:pPr>
-            <a:r>
-              <a:rPr sz="2200">
-                <a:solidFill>
-                  <a:srgbClr val="101010"/>
-                </a:solidFill>
-              </a:rPr>
-              <a:t>•  k = 16 (50/50 by layer count): rank 0 OOMs in the first forward.</a:t>
+              <a:rPr sz="1800">
+                <a:solidFill>
+                  <a:srgbClr val="101010"/>
+                </a:solidFill>
+              </a:rPr>
+              <a:t>•  Wall time: 72.1 min. Almost identical to DDP.</a:t>
+            </a:r>
+          </a:p>
+          <a:p>
+            <a:pPr>
+              <a:spcAft>
+                <a:spcPts val="800"/>
+              </a:spcAft>
+            </a:pPr>
+            <a:r>
+              <a:rPr sz="1800">
+                <a:solidFill>
+                  <a:srgbClr val="101010"/>
+                </a:solidFill>
+              </a:rPr>
+              <a:t>•  Throughput: 2.31 samples/sec — 1.04× DDP. Barely faster.</a:t>
+            </a:r>
+          </a:p>
+          <a:p>
+            <a:pPr>
+              <a:spcAft>
+                <a:spcPts val="800"/>
+              </a:spcAft>
+            </a:pPr>
+            <a:r>
+              <a:rPr sz="1800">
+                <a:solidFill>
+                  <a:srgbClr val="101010"/>
+                </a:solidFill>
+              </a:rPr>
+              <a:t>•  Effective batch 16, half of DDP, so fewer steps per epoch.</a:t>
+            </a:r>
+          </a:p>
+          <a:p>
+            <a:pPr>
+              <a:spcAft>
+                <a:spcPts val="800"/>
+              </a:spcAft>
+            </a:pPr>
+            <a:r>
+              <a:rPr sz="1800">
+                <a:solidFill>
+                  <a:srgbClr val="101010"/>
+                </a:solidFill>
+              </a:rPr>
+              <a:t>•  Peak GPU memory: 31.4 GiB on the heavier rank.</a:t>
+            </a:r>
+          </a:p>
+          <a:p>
+            <a:pPr>
+              <a:spcAft>
+                <a:spcPts val="800"/>
+              </a:spcAft>
+            </a:pPr>
+            <a:r>
+              <a:rPr sz="1800">
+                <a:solidFill>
+                  <a:srgbClr val="101010"/>
+                </a:solidFill>
+              </a:rPr>
+              <a:t>•  GPU utilization is uneven: rank 0 at 34%, rank 1 at 56%.</a:t>
             </a:r>
           </a:p>
           <a:p>
@@ -3502,27 +3547,12 @@
               </a:spcAft>
             </a:pPr>
             <a:r>
-              <a:rPr sz="1900">
+              <a:rPr sz="1500">
                 <a:solidFill>
                   <a:srgbClr val="555555"/>
                 </a:solidFill>
               </a:rPr>
-              <a:t>    –  Vision tower + image features sit on rank 0. With layers 0..15 it hits 31.4 GiB — over the 32 GiB card.</a:t>
-            </a:r>
-          </a:p>
-          <a:p>
-            <a:pPr>
-              <a:spcAft>
-                <a:spcPts val="800"/>
-              </a:spcAft>
-            </a:pPr>
-            <a:r>
-              <a:rPr sz="2200">
-                <a:solidFill>
-                  <a:srgbClr val="101010"/>
-                </a:solidFill>
-              </a:rPr>
-              <a:t>•  k = 8 (push work to rank 1): rank 1 OOMs.</a:t>
+              <a:t>    –  Whichever rank finishes its layers first sits idle until the other catches up.</a:t>
             </a:r>
           </a:p>
           <a:p>
@@ -3532,61 +3562,70 @@
               </a:spcAft>
             </a:pPr>
             <a:r>
-              <a:rPr sz="1900">
+              <a:rPr sz="1500">
                 <a:solidFill>
                   <a:srgbClr val="555555"/>
                 </a:solidFill>
               </a:rPr>
-              <a:t>    –  LM head + final norm + layers 8..31 hit 31.0 GiB.</a:t>
-            </a:r>
-          </a:p>
-          <a:p>
-            <a:pPr>
-              <a:spcAft>
-                <a:spcPts val="800"/>
-              </a:spcAft>
-            </a:pPr>
-            <a:r>
-              <a:rPr sz="2200">
-                <a:solidFill>
-                  <a:srgbClr val="101010"/>
-                </a:solidFill>
-              </a:rPr>
-              <a:t>•  k = 12 with microbatch 1 + grad accum 16: both ranks fit.</a:t>
-            </a:r>
-          </a:p>
-          <a:p>
-            <a:pPr lvl="1">
-              <a:spcAft>
-                <a:spcPts val="400"/>
-              </a:spcAft>
-            </a:pPr>
-            <a:r>
-              <a:rPr sz="1900">
-                <a:solidFill>
-                  <a:srgbClr val="555555"/>
-                </a:solidFill>
-              </a:rPr>
-              <a:t>    –  Rank 1 ≈ 31.4 GiB, rank 0 ≈ 28 GiB. Run completes 625/625 steps.</a:t>
-            </a:r>
-          </a:p>
-          <a:p>
-            <a:pPr>
-              <a:spcAft>
-                <a:spcPts val="800"/>
-              </a:spcAft>
-            </a:pPr>
-            <a:r>
-              <a:rPr sz="2200">
-                <a:solidFill>
-                  <a:srgbClr val="101010"/>
-                </a:solidFill>
-              </a:rPr>
-              <a:t>•  Lesson: layer count is a poor proxy for memory cost. The vision tower and LM head are heavier than they look.</a:t>
-            </a:r>
-          </a:p>
-        </p:txBody>
-      </p:sp>
+              <a:t>    –  Gloo is much slower than NCCL, so the comm gap is wider.</a:t>
+            </a:r>
+          </a:p>
+          <a:p>
+            <a:pPr>
+              <a:spcAft>
+                <a:spcPts val="800"/>
+              </a:spcAft>
+            </a:pPr>
+            <a:r>
+              <a:rPr sz="1800">
+                <a:solidFill>
+                  <a:srgbClr val="101010"/>
+                </a:solidFill>
+              </a:rPr>
+              <a:t>•  Final loss: 1.57 — higher than DDP because of the smaller effective batch.</a:t>
+            </a:r>
+          </a:p>
+          <a:p>
+            <a:pPr>
+              <a:spcAft>
+                <a:spcPts val="800"/>
+              </a:spcAft>
+            </a:pPr>
+            <a:r>
+              <a:rPr sz="1800">
+                <a:solidFill>
+                  <a:srgbClr val="101010"/>
+                </a:solidFill>
+              </a:rPr>
+              <a:t>•  Pipeline made the model fit. It did not make it faster.</a:t>
+            </a:r>
+          </a:p>
+        </p:txBody>
+      </p:sp>
+      <p:pic>
+        <p:nvPicPr>
+          <p:cNvPr id="4" name="Picture 3" descr="gpu_utilization_curve.png"/>
+          <p:cNvPicPr>
+            <a:picLocks noChangeAspect="1"/>
+          </p:cNvPicPr>
+          <p:nvPr/>
+        </p:nvPicPr>
+        <p:blipFill>
+          <a:blip r:embed="rId2"/>
+          <a:stretch>
+            <a:fillRect/>
+          </a:stretch>
+        </p:blipFill>
+        <p:spPr>
+          <a:xfrm>
+            <a:off x="6766560" y="1828800"/>
+            <a:ext cx="4937760" cy="3086100"/>
+          </a:xfrm>
+          <a:prstGeom prst="rect">
+            <a:avLst/>
+          </a:prstGeom>
+        </p:spPr>
+      </p:pic>
     </p:spTree>
   </p:cSld>
   <p:clrMapOvr>
@@ -3613,8 +3652,8 @@
         </p:nvSpPr>
         <p:spPr>
           <a:xfrm>
-            <a:off x="548640" y="365760"/>
-            <a:ext cx="11064240" cy="822960"/>
+            <a:off x="548640" y="2834640"/>
+            <a:ext cx="11064240" cy="1280160"/>
           </a:xfrm>
           <a:prstGeom prst="rect">
             <a:avLst/>
@@ -3627,200 +3666,18 @@
           </a:bodyPr>
           <a:lstStyle/>
           <a:p>
-            <a:pPr algn="l"/>
-            <a:r>
-              <a:rPr sz="3400" b="1">
-                <a:solidFill>
-                  <a:srgbClr val="101010"/>
-                </a:solidFill>
-              </a:rPr>
-              <a:t>Pipeline — results</a:t>
-            </a:r>
-          </a:p>
-        </p:txBody>
-      </p:sp>
-      <p:sp>
-        <p:nvSpPr>
-          <p:cNvPr id="3" name="TextBox 2"/>
-          <p:cNvSpPr txBox="1"/>
-          <p:nvPr/>
-        </p:nvSpPr>
-        <p:spPr>
-          <a:xfrm>
-            <a:off x="548640" y="1371600"/>
-            <a:ext cx="5852160" cy="5120640"/>
-          </a:xfrm>
-          <a:prstGeom prst="rect">
-            <a:avLst/>
-          </a:prstGeom>
-          <a:noFill/>
-        </p:spPr>
-        <p:txBody>
-          <a:bodyPr wrap="square" anchor="ctr">
-            <a:spAutoFit/>
-          </a:bodyPr>
-          <a:lstStyle/>
-          <a:p>
-            <a:pPr>
-              <a:spcAft>
-                <a:spcPts val="800"/>
-              </a:spcAft>
-            </a:pPr>
-            <a:r>
-              <a:rPr sz="1800">
-                <a:solidFill>
-                  <a:srgbClr val="101010"/>
-                </a:solidFill>
-              </a:rPr>
-              <a:t>•  Wall time: 72.1 min. Almost identical to DDP.</a:t>
-            </a:r>
-          </a:p>
-          <a:p>
-            <a:pPr>
-              <a:spcAft>
-                <a:spcPts val="800"/>
-              </a:spcAft>
-            </a:pPr>
-            <a:r>
-              <a:rPr sz="1800">
-                <a:solidFill>
-                  <a:srgbClr val="101010"/>
-                </a:solidFill>
-              </a:rPr>
-              <a:t>•  Throughput: 2.31 samples/sec — 1.04× DDP. Barely faster.</a:t>
-            </a:r>
-          </a:p>
-          <a:p>
-            <a:pPr>
-              <a:spcAft>
-                <a:spcPts val="800"/>
-              </a:spcAft>
-            </a:pPr>
-            <a:r>
-              <a:rPr sz="1800">
-                <a:solidFill>
-                  <a:srgbClr val="101010"/>
-                </a:solidFill>
-              </a:rPr>
-              <a:t>•  Effective batch 16, half of DDP, so fewer steps per epoch.</a:t>
-            </a:r>
-          </a:p>
-          <a:p>
-            <a:pPr>
-              <a:spcAft>
-                <a:spcPts val="800"/>
-              </a:spcAft>
-            </a:pPr>
-            <a:r>
-              <a:rPr sz="1800">
-                <a:solidFill>
-                  <a:srgbClr val="101010"/>
-                </a:solidFill>
-              </a:rPr>
-              <a:t>•  Peak GPU memory: 31.4 GiB on the heavier rank.</a:t>
-            </a:r>
-          </a:p>
-          <a:p>
-            <a:pPr>
-              <a:spcAft>
-                <a:spcPts val="800"/>
-              </a:spcAft>
-            </a:pPr>
-            <a:r>
-              <a:rPr sz="1800">
-                <a:solidFill>
-                  <a:srgbClr val="101010"/>
-                </a:solidFill>
-              </a:rPr>
-              <a:t>•  GPU utilization is uneven: rank 0 at 34%, rank 1 at 56%.</a:t>
-            </a:r>
-          </a:p>
-          <a:p>
-            <a:pPr lvl="1">
-              <a:spcAft>
-                <a:spcPts val="400"/>
-              </a:spcAft>
-            </a:pPr>
-            <a:r>
-              <a:rPr sz="1500">
-                <a:solidFill>
-                  <a:srgbClr val="555555"/>
-                </a:solidFill>
-              </a:rPr>
-              <a:t>    –  Whichever rank finishes its layers first sits idle until the other catches up.</a:t>
-            </a:r>
-          </a:p>
-          <a:p>
-            <a:pPr lvl="1">
-              <a:spcAft>
-                <a:spcPts val="400"/>
-              </a:spcAft>
-            </a:pPr>
-            <a:r>
-              <a:rPr sz="1500">
-                <a:solidFill>
-                  <a:srgbClr val="555555"/>
-                </a:solidFill>
-              </a:rPr>
-              <a:t>    –  Gloo is much slower than NCCL, so the comm gap is wider.</a:t>
-            </a:r>
-          </a:p>
-          <a:p>
-            <a:pPr>
-              <a:spcAft>
-                <a:spcPts val="800"/>
-              </a:spcAft>
-            </a:pPr>
-            <a:r>
-              <a:rPr sz="1800">
-                <a:solidFill>
-                  <a:srgbClr val="101010"/>
-                </a:solidFill>
-              </a:rPr>
-              <a:t>•  Final loss: 1.57 — higher than DDP because of the smaller effective batch.</a:t>
-            </a:r>
-          </a:p>
-          <a:p>
-            <a:pPr>
-              <a:spcAft>
-                <a:spcPts val="800"/>
-              </a:spcAft>
-            </a:pPr>
-            <a:r>
-              <a:rPr sz="1800">
-                <a:solidFill>
-                  <a:srgbClr val="101010"/>
-                </a:solidFill>
-              </a:rPr>
-              <a:t>•  Pipeline made the model fit. It did not make it faster.</a:t>
-            </a:r>
-          </a:p>
-        </p:txBody>
-      </p:sp>
-      <p:pic>
-        <p:nvPicPr>
-          <p:cNvPr id="4" name="Picture 3" descr="gpu_utilization_curve.png"/>
-          <p:cNvPicPr>
-            <a:picLocks noChangeAspect="1"/>
-          </p:cNvPicPr>
-          <p:nvPr/>
-        </p:nvPicPr>
-        <p:blipFill>
-          <a:blip r:embed="rId2"/>
-          <a:stretch>
-            <a:fillRect/>
-          </a:stretch>
-        </p:blipFill>
-        <p:spPr>
-          <a:xfrm>
-            <a:off x="6766560" y="1828800"/>
-            <a:ext cx="4937760" cy="3086100"/>
-          </a:xfrm>
-          <a:prstGeom prst="rect">
-            <a:avLst/>
-          </a:prstGeom>
-        </p:spPr>
-      </p:pic>
+            <a:pPr algn="ctr"/>
+            <a:r>
+              <a:rPr sz="5400" b="0">
+                <a:solidFill>
+                  <a:srgbClr val="101010"/>
+                </a:solidFill>
+              </a:rPr>
+              <a:t>DeepSpeed ZeRO-1 / ZeRO-2</a:t>
+            </a:r>
+          </a:p>
+        </p:txBody>
+      </p:sp>
     </p:spTree>
   </p:cSld>
   <p:clrMapOvr>
@@ -3847,8 +3704,8 @@
         </p:nvSpPr>
         <p:spPr>
           <a:xfrm>
-            <a:off x="548640" y="2834640"/>
-            <a:ext cx="11064240" cy="1280160"/>
+            <a:off x="548640" y="365760"/>
+            <a:ext cx="11064240" cy="822960"/>
           </a:xfrm>
           <a:prstGeom prst="rect">
             <a:avLst/>
@@ -3861,14 +3718,187 @@
           </a:bodyPr>
           <a:lstStyle/>
           <a:p>
-            <a:pPr algn="ctr"/>
-            <a:r>
-              <a:rPr sz="5400" b="0">
-                <a:solidFill>
-                  <a:srgbClr val="101010"/>
-                </a:solidFill>
-              </a:rPr>
-              <a:t>DeepSpeed ZeRO-2</a:t>
+            <a:pPr algn="l"/>
+            <a:r>
+              <a:rPr sz="3400" b="1">
+                <a:solidFill>
+                  <a:srgbClr val="101010"/>
+                </a:solidFill>
+              </a:rPr>
+              <a:t>ZeRO-1 vs ZeRO-2 (Omar)</a:t>
+            </a:r>
+          </a:p>
+        </p:txBody>
+      </p:sp>
+      <p:sp>
+        <p:nvSpPr>
+          <p:cNvPr id="3" name="TextBox 2"/>
+          <p:cNvSpPr txBox="1"/>
+          <p:nvPr/>
+        </p:nvSpPr>
+        <p:spPr>
+          <a:xfrm>
+            <a:off x="548640" y="1371600"/>
+            <a:ext cx="11064240" cy="5120640"/>
+          </a:xfrm>
+          <a:prstGeom prst="rect">
+            <a:avLst/>
+          </a:prstGeom>
+          <a:noFill/>
+        </p:spPr>
+        <p:txBody>
+          <a:bodyPr wrap="square" anchor="ctr">
+            <a:spAutoFit/>
+          </a:bodyPr>
+          <a:lstStyle/>
+          <a:p>
+            <a:pPr>
+              <a:spcAft>
+                <a:spcPts val="800"/>
+              </a:spcAft>
+            </a:pPr>
+            <a:r>
+              <a:rPr sz="2000">
+                <a:solidFill>
+                  <a:srgbClr val="101010"/>
+                </a:solidFill>
+              </a:rPr>
+              <a:t>•  Both are data parallelism with sharded state. The difference is what gets sharded.</a:t>
+            </a:r>
+          </a:p>
+          <a:p>
+            <a:pPr>
+              <a:spcAft>
+                <a:spcPts val="800"/>
+              </a:spcAft>
+            </a:pPr>
+            <a:r>
+              <a:rPr sz="2000">
+                <a:solidFill>
+                  <a:srgbClr val="101010"/>
+                </a:solidFill>
+              </a:rPr>
+              <a:t>•  ZeRO-1:</a:t>
+            </a:r>
+          </a:p>
+          <a:p>
+            <a:pPr lvl="1">
+              <a:spcAft>
+                <a:spcPts val="400"/>
+              </a:spcAft>
+            </a:pPr>
+            <a:r>
+              <a:rPr sz="1700">
+                <a:solidFill>
+                  <a:srgbClr val="555555"/>
+                </a:solidFill>
+              </a:rPr>
+              <a:t>    –  Optimizer states sharded. Gradients still AllReduce'd (like DDP), parameters replicated.</a:t>
+            </a:r>
+          </a:p>
+          <a:p>
+            <a:pPr lvl="1">
+              <a:spcAft>
+                <a:spcPts val="400"/>
+              </a:spcAft>
+            </a:pPr>
+            <a:r>
+              <a:rPr sz="1700">
+                <a:solidFill>
+                  <a:srgbClr val="555555"/>
+                </a:solidFill>
+              </a:rPr>
+              <a:t>    –  After the optimizer step, AllGather to put updated parameters back on every rank.</a:t>
+            </a:r>
+          </a:p>
+          <a:p>
+            <a:pPr>
+              <a:spcAft>
+                <a:spcPts val="800"/>
+              </a:spcAft>
+            </a:pPr>
+            <a:r>
+              <a:rPr sz="2000">
+                <a:solidFill>
+                  <a:srgbClr val="101010"/>
+                </a:solidFill>
+              </a:rPr>
+              <a:t>•  ZeRO-2 adds gradient sharding via ReduceScatter:</a:t>
+            </a:r>
+          </a:p>
+          <a:p>
+            <a:pPr lvl="1">
+              <a:spcAft>
+                <a:spcPts val="400"/>
+              </a:spcAft>
+            </a:pPr>
+            <a:r>
+              <a:rPr sz="1700">
+                <a:solidFill>
+                  <a:srgbClr val="555555"/>
+                </a:solidFill>
+              </a:rPr>
+              <a:t>    –  Gradients land on their owner-rank shards directly, no AllReduce.</a:t>
+            </a:r>
+          </a:p>
+          <a:p>
+            <a:pPr lvl="1">
+              <a:spcAft>
+                <a:spcPts val="400"/>
+              </a:spcAft>
+            </a:pPr>
+            <a:r>
+              <a:rPr sz="1700">
+                <a:solidFill>
+                  <a:srgbClr val="555555"/>
+                </a:solidFill>
+              </a:rPr>
+              <a:t>    –  Each rank takes one optimizer step on its shard, then AllGather params back.</a:t>
+            </a:r>
+          </a:p>
+          <a:p>
+            <a:pPr lvl="1">
+              <a:spcAft>
+                <a:spcPts val="400"/>
+              </a:spcAft>
+            </a:pPr>
+            <a:r>
+              <a:rPr sz="1700">
+                <a:solidFill>
+                  <a:srgbClr val="555555"/>
+                </a:solidFill>
+              </a:rPr>
+              <a:t>    –  Comm volume per step is roughly 1.5× the model size — same as ZeRO-1, different schedule.</a:t>
+            </a:r>
+          </a:p>
+          <a:p>
+            <a:pPr>
+              <a:spcAft>
+                <a:spcPts val="800"/>
+              </a:spcAft>
+            </a:pPr>
+            <a:r>
+              <a:rPr sz="2000">
+                <a:solidFill>
+                  <a:srgbClr val="101010"/>
+                </a:solidFill>
+              </a:rPr>
+              <a:t>•  On a LoRA workload, both win mostly from DeepSpeed's bucketed async overlap, not from the sharding itself.</a:t>
+            </a:r>
+          </a:p>
+          <a:p>
+            <a:pPr lvl="1">
+              <a:spcAft>
+                <a:spcPts val="400"/>
+              </a:spcAft>
+            </a:pPr>
+            <a:r>
+              <a:rPr sz="1700">
+                <a:solidFill>
+                  <a:srgbClr val="555555"/>
+                </a:solidFill>
+              </a:rPr>
+              <a:t>    –  ZeRO-1 throughput is between DDP and ZeRO-2; ZeRO-2 is fastest because ReduceScatter overlaps better with backward.</a:t>
             </a:r>
           </a:p>
         </p:txBody>
@@ -3920,7 +3950,7 @@
                   <a:srgbClr val="101010"/>
                 </a:solidFill>
               </a:rPr>
-              <a:t>What ZeRO-2 actually does (Omar)</a:t>
+              <a:t>ZeRO-1 / ZeRO-2 — results</a:t>
             </a:r>
           </a:p>
         </p:txBody>
@@ -3934,7 +3964,7 @@
         <p:spPr>
           <a:xfrm>
             <a:off x="548640" y="1371600"/>
-            <a:ext cx="11064240" cy="5120640"/>
+            <a:ext cx="5852160" cy="5120640"/>
           </a:xfrm>
           <a:prstGeom prst="rect">
             <a:avLst/>
@@ -3953,27 +3983,42 @@
               </a:spcAft>
             </a:pPr>
             <a:r>
-              <a:rPr sz="2000">
-                <a:solidFill>
-                  <a:srgbClr val="101010"/>
-                </a:solidFill>
-              </a:rPr>
-              <a:t>•  Still data parallelism: each rank trains on a different microbatch.</a:t>
-            </a:r>
-          </a:p>
-          <a:p>
-            <a:pPr>
-              <a:spcAft>
-                <a:spcPts val="800"/>
-              </a:spcAft>
-            </a:pPr>
-            <a:r>
-              <a:rPr sz="2000">
-                <a:solidFill>
-                  <a:srgbClr val="101010"/>
-                </a:solidFill>
-              </a:rPr>
-              <a:t>•  What's sharded across the two ranks vs DDP:</a:t>
+              <a:rPr sz="1800">
+                <a:solidFill>
+                  <a:srgbClr val="101010"/>
+                </a:solidFill>
+              </a:rPr>
+              <a:t>•  Both at effective batch 32, full epoch (313 steps).</a:t>
+            </a:r>
+          </a:p>
+          <a:p>
+            <a:pPr>
+              <a:spcAft>
+                <a:spcPts val="800"/>
+              </a:spcAft>
+            </a:pPr>
+            <a:r>
+              <a:rPr sz="1800">
+                <a:solidFill>
+                  <a:srgbClr val="101010"/>
+                </a:solidFill>
+              </a:rPr>
+              <a:t>•  ZeRO-1: 65 min, 2.56 sps, 28.8 GiB, 81% util, loss 1.14 — 1.15× DDP.</a:t>
+            </a:r>
+          </a:p>
+          <a:p>
+            <a:pPr>
+              <a:spcAft>
+                <a:spcPts val="800"/>
+              </a:spcAft>
+            </a:pPr>
+            <a:r>
+              <a:rPr sz="1800">
+                <a:solidFill>
+                  <a:srgbClr val="101010"/>
+                </a:solidFill>
+              </a:rPr>
+              <a:t>•  ZeRO-2: 58 min, 2.85 sps, 27.6 GiB, 89% util, loss 1.11 — 1.28× DDP.</a:t>
             </a:r>
           </a:p>
           <a:p>
@@ -3983,136 +4028,70 @@
               </a:spcAft>
             </a:pPr>
             <a:r>
-              <a:rPr sz="1700">
+              <a:rPr sz="1500">
                 <a:solidFill>
                   <a:srgbClr val="555555"/>
                 </a:solidFill>
               </a:rPr>
-              <a:t>    –  Optimizer states (AdamW m, v) — sharded.</a:t>
-            </a:r>
-          </a:p>
-          <a:p>
-            <a:pPr lvl="1">
-              <a:spcAft>
-                <a:spcPts val="400"/>
-              </a:spcAft>
-            </a:pPr>
-            <a:r>
-              <a:rPr sz="1700">
-                <a:solidFill>
-                  <a:srgbClr val="555555"/>
-                </a:solidFill>
-              </a:rPr>
-              <a:t>    –  Gradients — sharded after backward via ReduceScatter.</a:t>
-            </a:r>
-          </a:p>
-          <a:p>
-            <a:pPr lvl="1">
-              <a:spcAft>
-                <a:spcPts val="400"/>
-              </a:spcAft>
-            </a:pPr>
-            <a:r>
-              <a:rPr sz="1700">
-                <a:solidFill>
-                  <a:srgbClr val="555555"/>
-                </a:solidFill>
-              </a:rPr>
-              <a:t>    –  Parameters — still replicated on every rank.</a:t>
-            </a:r>
-          </a:p>
-          <a:p>
-            <a:pPr>
-              <a:spcAft>
-                <a:spcPts val="800"/>
-              </a:spcAft>
-            </a:pPr>
-            <a:r>
-              <a:rPr sz="2000">
-                <a:solidFill>
-                  <a:srgbClr val="101010"/>
-                </a:solidFill>
-              </a:rPr>
-              <a:t>•  Per-step communication:</a:t>
-            </a:r>
-          </a:p>
-          <a:p>
-            <a:pPr lvl="1">
-              <a:spcAft>
-                <a:spcPts val="400"/>
-              </a:spcAft>
-            </a:pPr>
-            <a:r>
-              <a:rPr sz="1700">
-                <a:solidFill>
-                  <a:srgbClr val="555555"/>
-                </a:solidFill>
-              </a:rPr>
-              <a:t>    –  Backward pass ReduceScatters the gradients to their owner-rank shards.</a:t>
-            </a:r>
-          </a:p>
-          <a:p>
-            <a:pPr lvl="1">
-              <a:spcAft>
-                <a:spcPts val="400"/>
-              </a:spcAft>
-            </a:pPr>
-            <a:r>
-              <a:rPr sz="1700">
-                <a:solidFill>
-                  <a:srgbClr val="555555"/>
-                </a:solidFill>
-              </a:rPr>
-              <a:t>    –  Each rank takes one optimizer step on its shard.</a:t>
-            </a:r>
-          </a:p>
-          <a:p>
-            <a:pPr lvl="1">
-              <a:spcAft>
-                <a:spcPts val="400"/>
-              </a:spcAft>
-            </a:pPr>
-            <a:r>
-              <a:rPr sz="1700">
-                <a:solidFill>
-                  <a:srgbClr val="555555"/>
-                </a:solidFill>
-              </a:rPr>
-              <a:t>    –  AllGather puts the updated parameters back on every rank.</a:t>
-            </a:r>
-          </a:p>
-          <a:p>
-            <a:pPr>
-              <a:spcAft>
-                <a:spcPts val="800"/>
-              </a:spcAft>
-            </a:pPr>
-            <a:r>
-              <a:rPr sz="2000">
-                <a:solidFill>
-                  <a:srgbClr val="101010"/>
-                </a:solidFill>
-              </a:rPr>
-              <a:t>•  On paper this saves a lot of memory. On a LoRA workload it doesn't, because the trainable optimizer state is already small.</a:t>
-            </a:r>
-          </a:p>
-          <a:p>
-            <a:pPr lvl="1">
-              <a:spcAft>
-                <a:spcPts val="400"/>
-              </a:spcAft>
-            </a:pPr>
-            <a:r>
-              <a:rPr sz="1700">
-                <a:solidFill>
-                  <a:srgbClr val="555555"/>
-                </a:solidFill>
-              </a:rPr>
-              <a:t>    –  The real win comes from DeepSpeed's bucketed async overlap, not from sharding.</a:t>
-            </a:r>
-          </a:p>
-        </p:txBody>
-      </p:sp>
+              <a:t>    –  The only method that beats plain DDP outright.</a:t>
+            </a:r>
+          </a:p>
+          <a:p>
+            <a:pPr>
+              <a:spcAft>
+                <a:spcPts val="800"/>
+              </a:spcAft>
+            </a:pPr>
+            <a:r>
+              <a:rPr sz="1800">
+                <a:solidFill>
+                  <a:srgbClr val="101010"/>
+                </a:solidFill>
+              </a:rPr>
+              <a:t>•  Why ZeRO-2 edges out ZeRO-1: ReduceScatter overlaps with the backward pass, AllReduce doesn't as cleanly.</a:t>
+            </a:r>
+          </a:p>
+          <a:p>
+            <a:pPr>
+              <a:spcAft>
+                <a:spcPts val="800"/>
+              </a:spcAft>
+            </a:pPr>
+            <a:r>
+              <a:rPr sz="1800">
+                <a:solidFill>
+                  <a:srgbClr val="101010"/>
+                </a:solidFill>
+              </a:rPr>
+              <a:t>•  Why the speedup over DDP isn't 2×: LoRA's optimizer state is tiny — most of the win is overlap, not sharding.</a:t>
+            </a:r>
+          </a:p>
+        </p:txBody>
+      </p:sp>
+      <p:pic>
+        <p:nvPicPr>
+          <p:cNvPr id="4" name="Picture 3" descr="gpu_utilization_curve.png"/>
+          <p:cNvPicPr>
+            <a:picLocks noChangeAspect="1"/>
+          </p:cNvPicPr>
+          <p:nvPr/>
+        </p:nvPicPr>
+        <p:blipFill>
+          <a:blip r:embed="rId2"/>
+          <a:stretch>
+            <a:fillRect/>
+          </a:stretch>
+        </p:blipFill>
+        <p:spPr>
+          <a:xfrm>
+            <a:off x="6766560" y="1828800"/>
+            <a:ext cx="4937760" cy="3086100"/>
+          </a:xfrm>
+          <a:prstGeom prst="rect">
+            <a:avLst/>
+          </a:prstGeom>
+        </p:spPr>
+      </p:pic>
     </p:spTree>
   </p:cSld>
   <p:clrMapOvr>
@@ -4139,8 +4118,8 @@
         </p:nvSpPr>
         <p:spPr>
           <a:xfrm>
-            <a:off x="548640" y="365760"/>
-            <a:ext cx="11064240" cy="822960"/>
+            <a:off x="548640" y="2834640"/>
+            <a:ext cx="11064240" cy="1280160"/>
           </a:xfrm>
           <a:prstGeom prst="rect">
             <a:avLst/>
@@ -4153,215 +4132,18 @@
           </a:bodyPr>
           <a:lstStyle/>
           <a:p>
-            <a:pPr algn="l"/>
-            <a:r>
-              <a:rPr sz="3400" b="1">
-                <a:solidFill>
-                  <a:srgbClr val="101010"/>
-                </a:solidFill>
-              </a:rPr>
-              <a:t>ZeRO-2 — results</a:t>
-            </a:r>
-          </a:p>
-        </p:txBody>
-      </p:sp>
-      <p:sp>
-        <p:nvSpPr>
-          <p:cNvPr id="3" name="TextBox 2"/>
-          <p:cNvSpPr txBox="1"/>
-          <p:nvPr/>
-        </p:nvSpPr>
-        <p:spPr>
-          <a:xfrm>
-            <a:off x="548640" y="1371600"/>
-            <a:ext cx="5852160" cy="5120640"/>
-          </a:xfrm>
-          <a:prstGeom prst="rect">
-            <a:avLst/>
-          </a:prstGeom>
-          <a:noFill/>
-        </p:spPr>
-        <p:txBody>
-          <a:bodyPr wrap="square" anchor="ctr">
-            <a:spAutoFit/>
-          </a:bodyPr>
-          <a:lstStyle/>
-          <a:p>
-            <a:pPr>
-              <a:spcAft>
-                <a:spcPts val="800"/>
-              </a:spcAft>
-            </a:pPr>
-            <a:r>
-              <a:rPr sz="1800">
-                <a:solidFill>
-                  <a:srgbClr val="101010"/>
-                </a:solidFill>
-              </a:rPr>
-              <a:t>•  Wall time: 58.4 min — 16 minutes faster than DDP, 22% less wall-clock.</a:t>
-            </a:r>
-          </a:p>
-          <a:p>
-            <a:pPr>
-              <a:spcAft>
-                <a:spcPts val="800"/>
-              </a:spcAft>
-            </a:pPr>
-            <a:r>
-              <a:rPr sz="1800">
-                <a:solidFill>
-                  <a:srgbClr val="101010"/>
-                </a:solidFill>
-              </a:rPr>
-              <a:t>•  Throughput: 2.85 samples/sec — 1.28× DDP.</a:t>
-            </a:r>
-          </a:p>
-          <a:p>
-            <a:pPr>
-              <a:spcAft>
-                <a:spcPts val="800"/>
-              </a:spcAft>
-            </a:pPr>
-            <a:r>
-              <a:rPr sz="1800">
-                <a:solidFill>
-                  <a:srgbClr val="101010"/>
-                </a:solidFill>
-              </a:rPr>
-              <a:t>•  Peak GPU memory: 27.6 GiB. About 3 GiB lower than DDP.</a:t>
-            </a:r>
-          </a:p>
-          <a:p>
-            <a:pPr>
-              <a:spcAft>
-                <a:spcPts val="800"/>
-              </a:spcAft>
-            </a:pPr>
-            <a:r>
-              <a:rPr sz="1800">
-                <a:solidFill>
-                  <a:srgbClr val="101010"/>
-                </a:solidFill>
-              </a:rPr>
-              <a:t>•  GPU utilization: 88.5% (DDP was 70.7%).</a:t>
-            </a:r>
-          </a:p>
-          <a:p>
-            <a:pPr lvl="1">
-              <a:spcAft>
-                <a:spcPts val="400"/>
-              </a:spcAft>
-            </a:pPr>
-            <a:r>
-              <a:rPr sz="1500">
-                <a:solidFill>
-                  <a:srgbClr val="555555"/>
-                </a:solidFill>
-              </a:rPr>
-              <a:t>    –  DeepSpeed's overlap fills the AllReduce-stall gap that DDP couldn't hide.</a:t>
-            </a:r>
-          </a:p>
-          <a:p>
-            <a:pPr>
-              <a:spcAft>
-                <a:spcPts val="800"/>
-              </a:spcAft>
-            </a:pPr>
-            <a:r>
-              <a:rPr sz="1800">
-                <a:solidFill>
-                  <a:srgbClr val="101010"/>
-                </a:solidFill>
-              </a:rPr>
-              <a:t>•  Final loss: 1.11 — same as DDP within noise.</a:t>
-            </a:r>
-          </a:p>
-          <a:p>
-            <a:pPr>
-              <a:spcAft>
-                <a:spcPts val="800"/>
-              </a:spcAft>
-            </a:pPr>
-            <a:r>
-              <a:rPr sz="1800">
-                <a:solidFill>
-                  <a:srgbClr val="101010"/>
-                </a:solidFill>
-              </a:rPr>
-              <a:t>•  Why isn't the speedup closer to 2×?</a:t>
-            </a:r>
-          </a:p>
-          <a:p>
-            <a:pPr lvl="1">
-              <a:spcAft>
-                <a:spcPts val="400"/>
-              </a:spcAft>
-            </a:pPr>
-            <a:r>
-              <a:rPr sz="1500">
-                <a:solidFill>
-                  <a:srgbClr val="555555"/>
-                </a:solidFill>
-              </a:rPr>
-              <a:t>    –  LoRA's optimizer state is tiny, so there isn't much to shard.</a:t>
-            </a:r>
-          </a:p>
-          <a:p>
-            <a:pPr lvl="1">
-              <a:spcAft>
-                <a:spcPts val="400"/>
-              </a:spcAft>
-            </a:pPr>
-            <a:r>
-              <a:rPr sz="1500">
-                <a:solidFill>
-                  <a:srgbClr val="555555"/>
-                </a:solidFill>
-              </a:rPr>
-              <a:t>    –  Most of the win is the better overlap, not the sharding itself.</a:t>
-            </a:r>
-          </a:p>
-          <a:p>
-            <a:pPr>
-              <a:spcAft>
-                <a:spcPts val="800"/>
-              </a:spcAft>
-            </a:pPr>
-            <a:r>
-              <a:rPr sz="1800">
-                <a:solidFill>
-                  <a:srgbClr val="101010"/>
-                </a:solidFill>
-              </a:rPr>
-              <a:t>•  Even so: this is the only method in the comparison that beats plain DDP.</a:t>
-            </a:r>
-          </a:p>
-        </p:txBody>
-      </p:sp>
-      <p:pic>
-        <p:nvPicPr>
-          <p:cNvPr id="4" name="Picture 3" descr="gpu_utilization_curve.png"/>
-          <p:cNvPicPr>
-            <a:picLocks noChangeAspect="1"/>
-          </p:cNvPicPr>
-          <p:nvPr/>
-        </p:nvPicPr>
-        <p:blipFill>
-          <a:blip r:embed="rId2"/>
-          <a:stretch>
-            <a:fillRect/>
-          </a:stretch>
-        </p:blipFill>
-        <p:spPr>
-          <a:xfrm>
-            <a:off x="6766560" y="1828800"/>
-            <a:ext cx="4937760" cy="3086100"/>
-          </a:xfrm>
-          <a:prstGeom prst="rect">
-            <a:avLst/>
-          </a:prstGeom>
-        </p:spPr>
-      </p:pic>
+            <a:pPr algn="ctr"/>
+            <a:r>
+              <a:rPr sz="5400" b="0">
+                <a:solidFill>
+                  <a:srgbClr val="101010"/>
+                </a:solidFill>
+              </a:rPr>
+              <a:t>DeepSpeed ZeRO-3</a:t>
+            </a:r>
+          </a:p>
+        </p:txBody>
+      </p:sp>
     </p:spTree>
   </p:cSld>
   <p:clrMapOvr>
@@ -4388,8 +4170,8 @@
         </p:nvSpPr>
         <p:spPr>
           <a:xfrm>
-            <a:off x="548640" y="2834640"/>
-            <a:ext cx="11064240" cy="1280160"/>
+            <a:off x="548640" y="365760"/>
+            <a:ext cx="11064240" cy="822960"/>
           </a:xfrm>
           <a:prstGeom prst="rect">
             <a:avLst/>
@@ -4402,14 +4184,217 @@
           </a:bodyPr>
           <a:lstStyle/>
           <a:p>
-            <a:pPr algn="ctr"/>
-            <a:r>
-              <a:rPr sz="5400" b="0">
-                <a:solidFill>
-                  <a:srgbClr val="101010"/>
-                </a:solidFill>
-              </a:rPr>
-              <a:t>DeepSpeed ZeRO-3</a:t>
+            <a:pPr algn="l"/>
+            <a:r>
+              <a:rPr sz="3400" b="1">
+                <a:solidFill>
+                  <a:srgbClr val="101010"/>
+                </a:solidFill>
+              </a:rPr>
+              <a:t>ZeRO-3: shard everything (Omar)</a:t>
+            </a:r>
+          </a:p>
+        </p:txBody>
+      </p:sp>
+      <p:sp>
+        <p:nvSpPr>
+          <p:cNvPr id="3" name="TextBox 2"/>
+          <p:cNvSpPr txBox="1"/>
+          <p:nvPr/>
+        </p:nvSpPr>
+        <p:spPr>
+          <a:xfrm>
+            <a:off x="548640" y="1371600"/>
+            <a:ext cx="11064240" cy="5120640"/>
+          </a:xfrm>
+          <a:prstGeom prst="rect">
+            <a:avLst/>
+          </a:prstGeom>
+          <a:noFill/>
+        </p:spPr>
+        <p:txBody>
+          <a:bodyPr wrap="square" anchor="ctr">
+            <a:spAutoFit/>
+          </a:bodyPr>
+          <a:lstStyle/>
+          <a:p>
+            <a:pPr>
+              <a:spcAft>
+                <a:spcPts val="800"/>
+              </a:spcAft>
+            </a:pPr>
+            <a:r>
+              <a:rPr sz="1800">
+                <a:solidFill>
+                  <a:srgbClr val="101010"/>
+                </a:solidFill>
+              </a:rPr>
+              <a:t>•  Same data-parallel semantics as ZeRO-2. Each rank still sees a different microbatch.</a:t>
+            </a:r>
+          </a:p>
+          <a:p>
+            <a:pPr>
+              <a:spcAft>
+                <a:spcPts val="800"/>
+              </a:spcAft>
+            </a:pPr>
+            <a:r>
+              <a:rPr sz="1800">
+                <a:solidFill>
+                  <a:srgbClr val="101010"/>
+                </a:solidFill>
+              </a:rPr>
+              <a:t>•  The difference: parameters are also sharded across the two ranks.</a:t>
+            </a:r>
+          </a:p>
+          <a:p>
+            <a:pPr>
+              <a:spcAft>
+                <a:spcPts val="800"/>
+              </a:spcAft>
+            </a:pPr>
+            <a:r>
+              <a:rPr sz="1800">
+                <a:solidFill>
+                  <a:srgbClr val="101010"/>
+                </a:solidFill>
+              </a:rPr>
+              <a:t>•  Per-step comm now happens at every layer, twice:</a:t>
+            </a:r>
+          </a:p>
+          <a:p>
+            <a:pPr lvl="1">
+              <a:spcAft>
+                <a:spcPts val="400"/>
+              </a:spcAft>
+            </a:pPr>
+            <a:r>
+              <a:rPr sz="1500">
+                <a:solidFill>
+                  <a:srgbClr val="555555"/>
+                </a:solidFill>
+              </a:rPr>
+              <a:t>    –  Forward pass: AllGather parameters for layer N → compute → drop them.</a:t>
+            </a:r>
+          </a:p>
+          <a:p>
+            <a:pPr lvl="1">
+              <a:spcAft>
+                <a:spcPts val="400"/>
+              </a:spcAft>
+            </a:pPr>
+            <a:r>
+              <a:rPr sz="1500">
+                <a:solidFill>
+                  <a:srgbClr val="555555"/>
+                </a:solidFill>
+              </a:rPr>
+              <a:t>    –  Backward pass: AllGather them again → compute gradients → drop again.</a:t>
+            </a:r>
+          </a:p>
+          <a:p>
+            <a:pPr lvl="1">
+              <a:spcAft>
+                <a:spcPts val="400"/>
+              </a:spcAft>
+            </a:pPr>
+            <a:r>
+              <a:rPr sz="1500">
+                <a:solidFill>
+                  <a:srgbClr val="555555"/>
+                </a:solidFill>
+              </a:rPr>
+              <a:t>    –  ReduceScatter the gradients at the end of backward, then run the optimizer on each shard.</a:t>
+            </a:r>
+          </a:p>
+          <a:p>
+            <a:pPr>
+              <a:spcAft>
+                <a:spcPts val="800"/>
+              </a:spcAft>
+            </a:pPr>
+            <a:r>
+              <a:rPr sz="1800">
+                <a:solidFill>
+                  <a:srgbClr val="101010"/>
+                </a:solidFill>
+              </a:rPr>
+              <a:t>•  On 2 ranks, ~7 GB of parameters live on each. But every layer briefly re-materializes its full ~430 MB on every rank.</a:t>
+            </a:r>
+          </a:p>
+          <a:p>
+            <a:pPr>
+              <a:spcAft>
+                <a:spcPts val="800"/>
+              </a:spcAft>
+            </a:pPr>
+            <a:r>
+              <a:rPr sz="1800">
+                <a:solidFill>
+                  <a:srgbClr val="101010"/>
+                </a:solidFill>
+              </a:rPr>
+              <a:t>•  Back-of-envelope per microbatch:</a:t>
+            </a:r>
+          </a:p>
+          <a:p>
+            <a:pPr lvl="1">
+              <a:spcAft>
+                <a:spcPts val="400"/>
+              </a:spcAft>
+            </a:pPr>
+            <a:r>
+              <a:rPr sz="1500">
+                <a:solidFill>
+                  <a:srgbClr val="555555"/>
+                </a:solidFill>
+              </a:rPr>
+              <a:t>    –  AllGather other rank's 7 GB shard, fwd + bwd → ~14 GB cross-node per microbatch.</a:t>
+            </a:r>
+          </a:p>
+          <a:p>
+            <a:pPr lvl="1">
+              <a:spcAft>
+                <a:spcPts val="400"/>
+              </a:spcAft>
+            </a:pPr>
+            <a:r>
+              <a:rPr sz="1500">
+                <a:solidFill>
+                  <a:srgbClr val="555555"/>
+                </a:solidFill>
+              </a:rPr>
+              <a:t>    –  × 4 microbatches per optimizer step + ReduceScatter at end ≈ ~63 GB on the wire per step.</a:t>
+            </a:r>
+          </a:p>
+          <a:p>
+            <a:pPr lvl="1">
+              <a:spcAft>
+                <a:spcPts val="400"/>
+              </a:spcAft>
+            </a:pPr>
+            <a:r>
+              <a:rPr sz="1500">
+                <a:solidFill>
+                  <a:srgbClr val="555555"/>
+                </a:solidFill>
+              </a:rPr>
+              <a:t>    –  Over 1 Gbps Ethernet that's minutes of pure comm — DeepSpeed bucketed-async overlap (50 MB) is the only thing keeping it tractable.</a:t>
+            </a:r>
+          </a:p>
+          <a:p>
+            <a:pPr>
+              <a:spcAft>
+                <a:spcPts val="800"/>
+              </a:spcAft>
+            </a:pPr>
+            <a:r>
+              <a:rPr sz="1800">
+                <a:solidFill>
+                  <a:srgbClr val="101010"/>
+                </a:solidFill>
+              </a:rPr>
+              <a:t>•  We used configs/zero3_bounded_async.json to cap allgather/reduce buckets.</a:t>
             </a:r>
           </a:p>
         </p:txBody>
@@ -4461,7 +4446,7 @@
                   <a:srgbClr val="101010"/>
                 </a:solidFill>
               </a:rPr>
-              <a:t>ZeRO-3: shard everything (Rassul)</a:t>
+              <a:t>ZeRO-3 — results</a:t>
             </a:r>
           </a:p>
         </p:txBody>
@@ -4494,42 +4479,12 @@
               </a:spcAft>
             </a:pPr>
             <a:r>
-              <a:rPr sz="1800">
-                <a:solidFill>
-                  <a:srgbClr val="101010"/>
-                </a:solidFill>
-              </a:rPr>
-              <a:t>•  Same data-parallel semantics as ZeRO-2. Each rank still sees a different microbatch.</a:t>
-            </a:r>
-          </a:p>
-          <a:p>
-            <a:pPr>
-              <a:spcAft>
-                <a:spcPts val="800"/>
-              </a:spcAft>
-            </a:pPr>
-            <a:r>
-              <a:rPr sz="1800">
-                <a:solidFill>
-                  <a:srgbClr val="101010"/>
-                </a:solidFill>
-              </a:rPr>
-              <a:t>•  The difference: parameters are also sharded across the two ranks.</a:t>
-            </a:r>
-          </a:p>
-          <a:p>
-            <a:pPr>
-              <a:spcAft>
-                <a:spcPts val="800"/>
-              </a:spcAft>
-            </a:pPr>
-            <a:r>
-              <a:rPr sz="1800">
-                <a:solidFill>
-                  <a:srgbClr val="101010"/>
-                </a:solidFill>
-              </a:rPr>
-              <a:t>•  Per-step comm now happens at every layer, twice:</a:t>
+              <a:rPr sz="2000">
+                <a:solidFill>
+                  <a:srgbClr val="101010"/>
+                </a:solidFill>
+              </a:rPr>
+              <a:t>•  Hit the SLURM time limit before finishing. Reached 292 of 1250 steps in 3 h 52 min.</a:t>
             </a:r>
           </a:p>
           <a:p>
@@ -4539,12 +4494,42 @@
               </a:spcAft>
             </a:pPr>
             <a:r>
-              <a:rPr sz="1500">
+              <a:rPr sz="1700">
                 <a:solidFill>
                   <a:srgbClr val="555555"/>
                 </a:solidFill>
               </a:rPr>
-              <a:t>    –  Forward pass: AllGather parameters for layer N → compute → drop them.</a:t>
+              <a:t>    –  Each step took about 48 seconds. Projected full run: 16.5 hours.</a:t>
+            </a:r>
+          </a:p>
+          <a:p>
+            <a:pPr>
+              <a:spcAft>
+                <a:spcPts val="800"/>
+              </a:spcAft>
+            </a:pPr>
+            <a:r>
+              <a:rPr sz="2000">
+                <a:solidFill>
+                  <a:srgbClr val="101010"/>
+                </a:solidFill>
+              </a:rPr>
+              <a:t>•  Throughput: 0.17 samples/sec — about 13× slower than DDP.</a:t>
+            </a:r>
+          </a:p>
+          <a:p>
+            <a:pPr>
+              <a:spcAft>
+                <a:spcPts val="800"/>
+              </a:spcAft>
+            </a:pPr>
+            <a:r>
+              <a:rPr sz="2000">
+                <a:solidFill>
+                  <a:srgbClr val="101010"/>
+                </a:solidFill>
+              </a:rPr>
+              <a:t>•  Peak GPU memory: 22 GiB — actual sharding showing up.</a:t>
             </a:r>
           </a:p>
           <a:p>
@@ -4554,12 +4539,27 @@
               </a:spcAft>
             </a:pPr>
             <a:r>
-              <a:rPr sz="1500">
+              <a:rPr sz="1700">
                 <a:solidFill>
                   <a:srgbClr val="555555"/>
                 </a:solidFill>
               </a:rPr>
-              <a:t>    –  Backward pass: AllGather them again → compute gradients → drop again.</a:t>
+              <a:t>    –  But memory was never the bottleneck on this card. Communication was.</a:t>
+            </a:r>
+          </a:p>
+          <a:p>
+            <a:pPr>
+              <a:spcAft>
+                <a:spcPts val="800"/>
+              </a:spcAft>
+            </a:pPr>
+            <a:r>
+              <a:rPr sz="2000">
+                <a:solidFill>
+                  <a:srgbClr val="101010"/>
+                </a:solidFill>
+              </a:rPr>
+              <a:t>•  GPU utilization: 99%. This is misleading.</a:t>
             </a:r>
           </a:p>
           <a:p>
@@ -4569,42 +4569,12 @@
               </a:spcAft>
             </a:pPr>
             <a:r>
-              <a:rPr sz="1500">
+              <a:rPr sz="1700">
                 <a:solidFill>
                   <a:srgbClr val="555555"/>
                 </a:solidFill>
               </a:rPr>
-              <a:t>    –  ReduceScatter the gradients at the end of backward, then run the optimizer on each shard.</a:t>
-            </a:r>
-          </a:p>
-          <a:p>
-            <a:pPr>
-              <a:spcAft>
-                <a:spcPts val="800"/>
-              </a:spcAft>
-            </a:pPr>
-            <a:r>
-              <a:rPr sz="1800">
-                <a:solidFill>
-                  <a:srgbClr val="101010"/>
-                </a:solidFill>
-              </a:rPr>
-              <a:t>•  On 2 ranks, ~7 GB of parameters live on each. But every layer briefly re-materializes its full ~430 MB on every rank.</a:t>
-            </a:r>
-          </a:p>
-          <a:p>
-            <a:pPr>
-              <a:spcAft>
-                <a:spcPts val="800"/>
-              </a:spcAft>
-            </a:pPr>
-            <a:r>
-              <a:rPr sz="1800">
-                <a:solidFill>
-                  <a:srgbClr val="101010"/>
-                </a:solidFill>
-              </a:rPr>
-              <a:t>•  Back-of-envelope for our model:</a:t>
+              <a:t>    –  DeepSpeed pipelines comm with compute, so 'utilization' includes time spent waiting on AllGather.</a:t>
             </a:r>
           </a:p>
           <a:p>
@@ -4614,42 +4584,42 @@
               </a:spcAft>
             </a:pPr>
             <a:r>
-              <a:rPr sz="1500">
+              <a:rPr sz="1700">
                 <a:solidFill>
                   <a:srgbClr val="555555"/>
                 </a:solidFill>
               </a:rPr>
-              <a:t>    –  32 transformer layers × 430 MB × 2 (fwd + bwd) ≈ 27.5 GB transferred per step.</a:t>
-            </a:r>
-          </a:p>
-          <a:p>
-            <a:pPr lvl="1">
-              <a:spcAft>
-                <a:spcPts val="400"/>
-              </a:spcAft>
-            </a:pPr>
-            <a:r>
-              <a:rPr sz="1500">
-                <a:solidFill>
-                  <a:srgbClr val="555555"/>
-                </a:solidFill>
-              </a:rPr>
-              <a:t>    –  Over 1 Gbps Ethernet: roughly 4 minutes of comm per step before any compute.</a:t>
-            </a:r>
-          </a:p>
-          <a:p>
-            <a:pPr>
-              <a:spcAft>
-                <a:spcPts val="800"/>
-              </a:spcAft>
-            </a:pPr>
-            <a:r>
-              <a:rPr sz="1800">
-                <a:solidFill>
-                  <a:srgbClr val="101010"/>
-                </a:solidFill>
-              </a:rPr>
-              <a:t>•  We used configs/zero3_bounded_async.json: bucketed allgather/reduce at 50 MB.</a:t>
+              <a:t>    –  High util doesn't mean fast — it means the engine kept the GPU busy on something.</a:t>
+            </a:r>
+          </a:p>
+          <a:p>
+            <a:pPr>
+              <a:spcAft>
+                <a:spcPts val="800"/>
+              </a:spcAft>
+            </a:pPr>
+            <a:r>
+              <a:rPr sz="2000">
+                <a:solidFill>
+                  <a:srgbClr val="101010"/>
+                </a:solidFill>
+              </a:rPr>
+              <a:t>•  Last logged loss: 1.31. Convergence was fine — the run was just too slow to finish.</a:t>
+            </a:r>
+          </a:p>
+          <a:p>
+            <a:pPr>
+              <a:spcAft>
+                <a:spcPts val="800"/>
+              </a:spcAft>
+            </a:pPr>
+            <a:r>
+              <a:rPr sz="2000">
+                <a:solidFill>
+                  <a:srgbClr val="101010"/>
+                </a:solidFill>
+              </a:rPr>
+              <a:t>•  Diagnosis: per-layer AllGather over 1 Gbps Ethernet is the wall.</a:t>
             </a:r>
           </a:p>
         </p:txBody>
@@ -4680,8 +4650,8 @@
         </p:nvSpPr>
         <p:spPr>
           <a:xfrm>
-            <a:off x="548640" y="365760"/>
-            <a:ext cx="11064240" cy="822960"/>
+            <a:off x="548640" y="2834640"/>
+            <a:ext cx="11064240" cy="1280160"/>
           </a:xfrm>
           <a:prstGeom prst="rect">
             <a:avLst/>
@@ -4694,187 +4664,14 @@
           </a:bodyPr>
           <a:lstStyle/>
           <a:p>
-            <a:pPr algn="l"/>
-            <a:r>
-              <a:rPr sz="3400" b="1">
-                <a:solidFill>
-                  <a:srgbClr val="101010"/>
-                </a:solidFill>
-              </a:rPr>
-              <a:t>ZeRO-3 — results</a:t>
-            </a:r>
-          </a:p>
-        </p:txBody>
-      </p:sp>
-      <p:sp>
-        <p:nvSpPr>
-          <p:cNvPr id="3" name="TextBox 2"/>
-          <p:cNvSpPr txBox="1"/>
-          <p:nvPr/>
-        </p:nvSpPr>
-        <p:spPr>
-          <a:xfrm>
-            <a:off x="548640" y="1371600"/>
-            <a:ext cx="11064240" cy="5120640"/>
-          </a:xfrm>
-          <a:prstGeom prst="rect">
-            <a:avLst/>
-          </a:prstGeom>
-          <a:noFill/>
-        </p:spPr>
-        <p:txBody>
-          <a:bodyPr wrap="square" anchor="ctr">
-            <a:spAutoFit/>
-          </a:bodyPr>
-          <a:lstStyle/>
-          <a:p>
-            <a:pPr>
-              <a:spcAft>
-                <a:spcPts val="800"/>
-              </a:spcAft>
-            </a:pPr>
-            <a:r>
-              <a:rPr sz="2000">
-                <a:solidFill>
-                  <a:srgbClr val="101010"/>
-                </a:solidFill>
-              </a:rPr>
-              <a:t>•  Hit the SLURM time limit before finishing. Reached 292 of 1250 steps in 3 h 52 min.</a:t>
-            </a:r>
-          </a:p>
-          <a:p>
-            <a:pPr lvl="1">
-              <a:spcAft>
-                <a:spcPts val="400"/>
-              </a:spcAft>
-            </a:pPr>
-            <a:r>
-              <a:rPr sz="1700">
-                <a:solidFill>
-                  <a:srgbClr val="555555"/>
-                </a:solidFill>
-              </a:rPr>
-              <a:t>    –  Each step took about 48 seconds. Projected full run: 16.5 hours.</a:t>
-            </a:r>
-          </a:p>
-          <a:p>
-            <a:pPr>
-              <a:spcAft>
-                <a:spcPts val="800"/>
-              </a:spcAft>
-            </a:pPr>
-            <a:r>
-              <a:rPr sz="2000">
-                <a:solidFill>
-                  <a:srgbClr val="101010"/>
-                </a:solidFill>
-              </a:rPr>
-              <a:t>•  Throughput: 0.17 samples/sec — about 13× slower than DDP.</a:t>
-            </a:r>
-          </a:p>
-          <a:p>
-            <a:pPr>
-              <a:spcAft>
-                <a:spcPts val="800"/>
-              </a:spcAft>
-            </a:pPr>
-            <a:r>
-              <a:rPr sz="2000">
-                <a:solidFill>
-                  <a:srgbClr val="101010"/>
-                </a:solidFill>
-              </a:rPr>
-              <a:t>•  Peak GPU memory: 22 GiB — actual sharding showing up.</a:t>
-            </a:r>
-          </a:p>
-          <a:p>
-            <a:pPr lvl="1">
-              <a:spcAft>
-                <a:spcPts val="400"/>
-              </a:spcAft>
-            </a:pPr>
-            <a:r>
-              <a:rPr sz="1700">
-                <a:solidFill>
-                  <a:srgbClr val="555555"/>
-                </a:solidFill>
-              </a:rPr>
-              <a:t>    –  But memory was never the bottleneck on this card. Communication was.</a:t>
-            </a:r>
-          </a:p>
-          <a:p>
-            <a:pPr>
-              <a:spcAft>
-                <a:spcPts val="800"/>
-              </a:spcAft>
-            </a:pPr>
-            <a:r>
-              <a:rPr sz="2000">
-                <a:solidFill>
-                  <a:srgbClr val="101010"/>
-                </a:solidFill>
-              </a:rPr>
-              <a:t>•  GPU utilization: 99%. This is misleading.</a:t>
-            </a:r>
-          </a:p>
-          <a:p>
-            <a:pPr lvl="1">
-              <a:spcAft>
-                <a:spcPts val="400"/>
-              </a:spcAft>
-            </a:pPr>
-            <a:r>
-              <a:rPr sz="1700">
-                <a:solidFill>
-                  <a:srgbClr val="555555"/>
-                </a:solidFill>
-              </a:rPr>
-              <a:t>    –  DeepSpeed pipelines comm with compute, so 'utilization' includes time spent waiting on AllGather.</a:t>
-            </a:r>
-          </a:p>
-          <a:p>
-            <a:pPr lvl="1">
-              <a:spcAft>
-                <a:spcPts val="400"/>
-              </a:spcAft>
-            </a:pPr>
-            <a:r>
-              <a:rPr sz="1700">
-                <a:solidFill>
-                  <a:srgbClr val="555555"/>
-                </a:solidFill>
-              </a:rPr>
-              <a:t>    –  High util doesn't mean fast — it means the engine kept the GPU busy on something.</a:t>
-            </a:r>
-          </a:p>
-          <a:p>
-            <a:pPr>
-              <a:spcAft>
-                <a:spcPts val="800"/>
-              </a:spcAft>
-            </a:pPr>
-            <a:r>
-              <a:rPr sz="2000">
-                <a:solidFill>
-                  <a:srgbClr val="101010"/>
-                </a:solidFill>
-              </a:rPr>
-              <a:t>•  Last logged loss: 1.31. Convergence was fine — the run was just too slow to finish.</a:t>
-            </a:r>
-          </a:p>
-          <a:p>
-            <a:pPr>
-              <a:spcAft>
-                <a:spcPts val="800"/>
-              </a:spcAft>
-            </a:pPr>
-            <a:r>
-              <a:rPr sz="2000">
-                <a:solidFill>
-                  <a:srgbClr val="101010"/>
-                </a:solidFill>
-              </a:rPr>
-              <a:t>•  Diagnosis: per-layer AllGather over 1 Gbps Ethernet is the wall.</a:t>
+            <a:pPr algn="ctr"/>
+            <a:r>
+              <a:rPr sz="5400" b="0">
+                <a:solidFill>
+                  <a:srgbClr val="101010"/>
+                </a:solidFill>
+              </a:rPr>
+              <a:t>PyTorch FSDP</a:t>
             </a:r>
           </a:p>
         </p:txBody>
@@ -4905,8 +4702,8 @@
         </p:nvSpPr>
         <p:spPr>
           <a:xfrm>
-            <a:off x="548640" y="2834640"/>
-            <a:ext cx="11064240" cy="1280160"/>
+            <a:off x="548640" y="365760"/>
+            <a:ext cx="11064240" cy="822960"/>
           </a:xfrm>
           <a:prstGeom prst="rect">
             <a:avLst/>
@@ -4919,14 +4716,172 @@
           </a:bodyPr>
           <a:lstStyle/>
           <a:p>
-            <a:pPr algn="ctr"/>
-            <a:r>
-              <a:rPr sz="5400" b="0">
-                <a:solidFill>
-                  <a:srgbClr val="101010"/>
-                </a:solidFill>
-              </a:rPr>
-              <a:t>PyTorch FSDP</a:t>
+            <a:pPr algn="l"/>
+            <a:r>
+              <a:rPr sz="3400" b="1">
+                <a:solidFill>
+                  <a:srgbClr val="101010"/>
+                </a:solidFill>
+              </a:rPr>
+              <a:t>FSDP: PyTorch's take (Rassul)</a:t>
+            </a:r>
+          </a:p>
+        </p:txBody>
+      </p:sp>
+      <p:sp>
+        <p:nvSpPr>
+          <p:cNvPr id="3" name="TextBox 2"/>
+          <p:cNvSpPr txBox="1"/>
+          <p:nvPr/>
+        </p:nvSpPr>
+        <p:spPr>
+          <a:xfrm>
+            <a:off x="548640" y="1371600"/>
+            <a:ext cx="11064240" cy="5120640"/>
+          </a:xfrm>
+          <a:prstGeom prst="rect">
+            <a:avLst/>
+          </a:prstGeom>
+          <a:noFill/>
+        </p:spPr>
+        <p:txBody>
+          <a:bodyPr wrap="square" anchor="ctr">
+            <a:spAutoFit/>
+          </a:bodyPr>
+          <a:lstStyle/>
+          <a:p>
+            <a:pPr>
+              <a:spcAft>
+                <a:spcPts val="800"/>
+              </a:spcAft>
+            </a:pPr>
+            <a:r>
+              <a:rPr sz="2000">
+                <a:solidFill>
+                  <a:srgbClr val="101010"/>
+                </a:solidFill>
+              </a:rPr>
+              <a:t>•  PyTorch-native equivalent of ZeRO-3. Same algorithm, different implementation.</a:t>
+            </a:r>
+          </a:p>
+          <a:p>
+            <a:pPr>
+              <a:spcAft>
+                <a:spcPts val="800"/>
+              </a:spcAft>
+            </a:pPr>
+            <a:r>
+              <a:rPr sz="2000">
+                <a:solidFill>
+                  <a:srgbClr val="101010"/>
+                </a:solidFill>
+              </a:rPr>
+              <a:t>•  Design choices that differ from DeepSpeed:</a:t>
+            </a:r>
+          </a:p>
+          <a:p>
+            <a:pPr lvl="1">
+              <a:spcAft>
+                <a:spcPts val="400"/>
+              </a:spcAft>
+            </a:pPr>
+            <a:r>
+              <a:rPr sz="1700">
+                <a:solidFill>
+                  <a:srgbClr val="555555"/>
+                </a:solidFill>
+              </a:rPr>
+              <a:t>    –  Each transformer block is wrapped as one FSDP unit (a contiguous FlatParameter).</a:t>
+            </a:r>
+          </a:p>
+          <a:p>
+            <a:pPr lvl="1">
+              <a:spcAft>
+                <a:spcPts val="400"/>
+              </a:spcAft>
+            </a:pPr>
+            <a:r>
+              <a:rPr sz="1700">
+                <a:solidFill>
+                  <a:srgbClr val="555555"/>
+                </a:solidFill>
+              </a:rPr>
+              <a:t>    –  AllGather happens at the unit boundary, not per-tensor.</a:t>
+            </a:r>
+          </a:p>
+          <a:p>
+            <a:pPr lvl="1">
+              <a:spcAft>
+                <a:spcPts val="400"/>
+              </a:spcAft>
+            </a:pPr>
+            <a:r>
+              <a:rPr sz="1700">
+                <a:solidFill>
+                  <a:srgbClr val="555555"/>
+                </a:solidFill>
+              </a:rPr>
+              <a:t>    –  Mixed precision is set explicitly via a policy (we used bf16).</a:t>
+            </a:r>
+          </a:p>
+          <a:p>
+            <a:pPr>
+              <a:spcAft>
+                <a:spcPts val="800"/>
+              </a:spcAft>
+            </a:pPr>
+            <a:r>
+              <a:rPr sz="2000">
+                <a:solidFill>
+                  <a:srgbClr val="101010"/>
+                </a:solidFill>
+              </a:rPr>
+              <a:t>•  Our config: full_shard auto_wrap on LlamaDecoderLayer, use_orig_params=True (required for LoRA), cpu_ram_efficient_loading=true.</a:t>
+            </a:r>
+          </a:p>
+          <a:p>
+            <a:pPr>
+              <a:spcAft>
+                <a:spcPts val="800"/>
+              </a:spcAft>
+            </a:pPr>
+            <a:r>
+              <a:rPr sz="2000">
+                <a:solidFill>
+                  <a:srgbClr val="101010"/>
+                </a:solidFill>
+              </a:rPr>
+              <a:t>•  Two LLaVA-specific bugs we had to patch to get this running:</a:t>
+            </a:r>
+          </a:p>
+          <a:p>
+            <a:pPr lvl="1">
+              <a:spcAft>
+                <a:spcPts val="400"/>
+              </a:spcAft>
+            </a:pPr>
+            <a:r>
+              <a:rPr sz="1700">
+                <a:solidFill>
+                  <a:srgbClr val="555555"/>
+                </a:solidFill>
+              </a:rPr>
+              <a:t>    –  self.vision_tower[0] crashes when loading from a vendored checkpoint where vision_tower isn't a list.</a:t>
+            </a:r>
+          </a:p>
+          <a:p>
+            <a:pPr lvl="1">
+              <a:spcAft>
+                <a:spcPts val="400"/>
+              </a:spcAft>
+            </a:pPr>
+            <a:r>
+              <a:rPr sz="1700">
+                <a:solidFill>
+                  <a:srgbClr val="555555"/>
+                </a:solidFill>
+              </a:rPr>
+              <a:t>    –  LoRA adapters are created in fp32 after the base model is cast to bf16. FSDP requires uniform dtype, so we cast LoRA to bf16 too.</a:t>
             </a:r>
           </a:p>
         </p:txBody>
@@ -5106,7 +5061,7 @@
                   <a:srgbClr val="555555"/>
                 </a:solidFill>
               </a:rPr>
-              <a:t>    –  DeepSpeed ZeRO-2 — Omar Ahmed</a:t>
+              <a:t>    –  DeepSpeed ZeRO-1, ZeRO-2, and ZeRO-3 — Omar Ahmed</a:t>
             </a:r>
           </a:p>
           <a:p>
@@ -5121,7 +5076,7 @@
                   <a:srgbClr val="555555"/>
                 </a:solidFill>
               </a:rPr>
-              <a:t>    –  DeepSpeed ZeRO-3 and PyTorch FSDP — Rassul Magauin</a:t>
+              <a:t>    –  PyTorch FSDP and Tensor Parallelism — Rassul Magauin</a:t>
             </a:r>
           </a:p>
         </p:txBody>
@@ -5173,7 +5128,7 @@
                   <a:srgbClr val="101010"/>
                 </a:solidFill>
               </a:rPr>
-              <a:t>FSDP: PyTorch's take (Rassul)</a:t>
+              <a:t>FSDP — results</a:t>
             </a:r>
           </a:p>
         </p:txBody>
@@ -5187,7 +5142,7 @@
         <p:spPr>
           <a:xfrm>
             <a:off x="548640" y="1371600"/>
-            <a:ext cx="11064240" cy="5120640"/>
+            <a:ext cx="5852160" cy="5120640"/>
           </a:xfrm>
           <a:prstGeom prst="rect">
             <a:avLst/>
@@ -5206,27 +5161,72 @@
               </a:spcAft>
             </a:pPr>
             <a:r>
-              <a:rPr sz="2000">
-                <a:solidFill>
-                  <a:srgbClr val="101010"/>
-                </a:solidFill>
-              </a:rPr>
-              <a:t>•  PyTorch-native equivalent of ZeRO-3. Same algorithm, different implementation.</a:t>
-            </a:r>
-          </a:p>
-          <a:p>
-            <a:pPr>
-              <a:spcAft>
-                <a:spcPts val="800"/>
-              </a:spcAft>
-            </a:pPr>
-            <a:r>
-              <a:rPr sz="2000">
-                <a:solidFill>
-                  <a:srgbClr val="101010"/>
-                </a:solidFill>
-              </a:rPr>
-              <a:t>•  Design choices that differ from DeepSpeed:</a:t>
+              <a:rPr sz="1800">
+                <a:solidFill>
+                  <a:srgbClr val="101010"/>
+                </a:solidFill>
+              </a:rPr>
+              <a:t>•  Ran to step 292 — matched ZeRO-3's stopping point — at 84 s/step.</a:t>
+            </a:r>
+          </a:p>
+          <a:p>
+            <a:pPr>
+              <a:spcAft>
+                <a:spcPts val="800"/>
+              </a:spcAft>
+            </a:pPr>
+            <a:r>
+              <a:rPr sz="1800">
+                <a:solidFill>
+                  <a:srgbClr val="101010"/>
+                </a:solidFill>
+              </a:rPr>
+              <a:t>•  Wall time: 6.8 h. Throughput: 0.095 sps — ~22× slower than DDP, ~1.8× slower than ZeRO-3.</a:t>
+            </a:r>
+          </a:p>
+          <a:p>
+            <a:pPr>
+              <a:spcAft>
+                <a:spcPts val="800"/>
+              </a:spcAft>
+            </a:pPr>
+            <a:r>
+              <a:rPr sz="1800">
+                <a:solidFill>
+                  <a:srgbClr val="101010"/>
+                </a:solidFill>
+              </a:rPr>
+              <a:t>•  Peak GPU memory: 31.6 GiB (right at the card's limit).</a:t>
+            </a:r>
+          </a:p>
+          <a:p>
+            <a:pPr>
+              <a:spcAft>
+                <a:spcPts val="800"/>
+              </a:spcAft>
+            </a:pPr>
+            <a:r>
+              <a:rPr sz="1800">
+                <a:solidFill>
+                  <a:srgbClr val="101010"/>
+                </a:solidFill>
+              </a:rPr>
+              <a:t>•  GPU utilization: 97.5%. Final loss: 1.34 — matches ZeRO-3 within noise (same algorithm).</a:t>
+            </a:r>
+          </a:p>
+          <a:p>
+            <a:pPr>
+              <a:spcAft>
+                <a:spcPts val="800"/>
+              </a:spcAft>
+            </a:pPr>
+            <a:r>
+              <a:rPr sz="1800">
+                <a:solidFill>
+                  <a:srgbClr val="101010"/>
+                </a:solidFill>
+              </a:rPr>
+              <a:t>•  Why slower than ZeRO-3 on the same hardware?</a:t>
             </a:r>
           </a:p>
           <a:p>
@@ -5236,12 +5236,12 @@
               </a:spcAft>
             </a:pPr>
             <a:r>
-              <a:rPr sz="1700">
+              <a:rPr sz="1500">
                 <a:solidFill>
                   <a:srgbClr val="555555"/>
                 </a:solidFill>
               </a:rPr>
-              <a:t>    –  Each transformer block is wrapped as one FSDP unit (a contiguous FlatParameter).</a:t>
+              <a:t>    –  DeepSpeed's bounded async (50 MB buckets) overlaps comm with compute aggressively.</a:t>
             </a:r>
           </a:p>
           <a:p>
@@ -5251,12 +5251,12 @@
               </a:spcAft>
             </a:pPr>
             <a:r>
-              <a:rPr sz="1700">
+              <a:rPr sz="1500">
                 <a:solidFill>
                   <a:srgbClr val="555555"/>
                 </a:solidFill>
               </a:rPr>
-              <a:t>    –  AllGather happens at the unit boundary, not per-tensor.</a:t>
+              <a:t>    –  FSDP's defaults wait for each block's AllGather to finish before computing.</a:t>
             </a:r>
           </a:p>
           <a:p>
@@ -5266,76 +5266,40 @@
               </a:spcAft>
             </a:pPr>
             <a:r>
-              <a:rPr sz="1700">
+              <a:rPr sz="1500">
                 <a:solidFill>
                   <a:srgbClr val="555555"/>
                 </a:solidFill>
               </a:rPr>
-              <a:t>    –  Mixed precision is set explicitly via a policy (we used bf16).</a:t>
-            </a:r>
-          </a:p>
-          <a:p>
-            <a:pPr>
-              <a:spcAft>
-                <a:spcPts val="800"/>
-              </a:spcAft>
-            </a:pPr>
-            <a:r>
-              <a:rPr sz="2000">
-                <a:solidFill>
-                  <a:srgbClr val="101010"/>
-                </a:solidFill>
-              </a:rPr>
-              <a:t>•  Our config: full_shard auto_wrap on LlamaDecoderLayer, use_orig_params=True (required for LoRA), cpu_ram_efficient_loading=true.</a:t>
-            </a:r>
-          </a:p>
-          <a:p>
-            <a:pPr>
-              <a:spcAft>
-                <a:spcPts val="800"/>
-              </a:spcAft>
-            </a:pPr>
-            <a:r>
-              <a:rPr sz="2000">
-                <a:solidFill>
-                  <a:srgbClr val="101010"/>
-                </a:solidFill>
-              </a:rPr>
-              <a:t>•  Two LLaVA-specific bugs we had to patch to get this running:</a:t>
-            </a:r>
-          </a:p>
-          <a:p>
-            <a:pPr lvl="1">
-              <a:spcAft>
-                <a:spcPts val="400"/>
-              </a:spcAft>
-            </a:pPr>
-            <a:r>
-              <a:rPr sz="1700">
-                <a:solidFill>
-                  <a:srgbClr val="555555"/>
-                </a:solidFill>
-              </a:rPr>
-              <a:t>    –  self.vision_tower[0] crashes when loading from a vendored checkpoint where vision_tower isn't a list.</a:t>
-            </a:r>
-          </a:p>
-          <a:p>
-            <a:pPr lvl="1">
-              <a:spcAft>
-                <a:spcPts val="400"/>
-              </a:spcAft>
-            </a:pPr>
-            <a:r>
-              <a:rPr sz="1700">
-                <a:solidFill>
-                  <a:srgbClr val="555555"/>
-                </a:solidFill>
-              </a:rPr>
-              <a:t>    –  LoRA adapters are created in fp32 after the base model is cast to bf16. FSDP requires uniform dtype, so we cast LoRA to bf16 too.</a:t>
-            </a:r>
-          </a:p>
-        </p:txBody>
-      </p:sp>
+              <a:t>    –  Same algorithm, different async behavior — the difference is real on a slow link.</a:t>
+            </a:r>
+          </a:p>
+        </p:txBody>
+      </p:sp>
+      <p:pic>
+        <p:nvPicPr>
+          <p:cNvPr id="4" name="Picture 3" descr="gpu_utilization_curve.png"/>
+          <p:cNvPicPr>
+            <a:picLocks noChangeAspect="1"/>
+          </p:cNvPicPr>
+          <p:nvPr/>
+        </p:nvPicPr>
+        <p:blipFill>
+          <a:blip r:embed="rId2"/>
+          <a:stretch>
+            <a:fillRect/>
+          </a:stretch>
+        </p:blipFill>
+        <p:spPr>
+          <a:xfrm>
+            <a:off x="6766560" y="1828800"/>
+            <a:ext cx="4937760" cy="3086100"/>
+          </a:xfrm>
+          <a:prstGeom prst="rect">
+            <a:avLst/>
+          </a:prstGeom>
+        </p:spPr>
+      </p:pic>
     </p:spTree>
   </p:cSld>
   <p:clrMapOvr>
@@ -5362,8 +5326,8 @@
         </p:nvSpPr>
         <p:spPr>
           <a:xfrm>
-            <a:off x="548640" y="365760"/>
-            <a:ext cx="11064240" cy="822960"/>
+            <a:off x="548640" y="2834640"/>
+            <a:ext cx="11064240" cy="1280160"/>
           </a:xfrm>
           <a:prstGeom prst="rect">
             <a:avLst/>
@@ -5376,230 +5340,18 @@
           </a:bodyPr>
           <a:lstStyle/>
           <a:p>
-            <a:pPr algn="l"/>
-            <a:r>
-              <a:rPr sz="3400" b="1">
-                <a:solidFill>
-                  <a:srgbClr val="101010"/>
-                </a:solidFill>
-              </a:rPr>
-              <a:t>FSDP — results</a:t>
-            </a:r>
-          </a:p>
-        </p:txBody>
-      </p:sp>
-      <p:sp>
-        <p:nvSpPr>
-          <p:cNvPr id="3" name="TextBox 2"/>
-          <p:cNvSpPr txBox="1"/>
-          <p:nvPr/>
-        </p:nvSpPr>
-        <p:spPr>
-          <a:xfrm>
-            <a:off x="548640" y="1371600"/>
-            <a:ext cx="5852160" cy="5120640"/>
-          </a:xfrm>
-          <a:prstGeom prst="rect">
-            <a:avLst/>
-          </a:prstGeom>
-          <a:noFill/>
-        </p:spPr>
-        <p:txBody>
-          <a:bodyPr wrap="square" anchor="ctr">
-            <a:spAutoFit/>
-          </a:bodyPr>
-          <a:lstStyle/>
-          <a:p>
-            <a:pPr>
-              <a:spcAft>
-                <a:spcPts val="800"/>
-              </a:spcAft>
-            </a:pPr>
-            <a:r>
-              <a:rPr sz="1700">
-                <a:solidFill>
-                  <a:srgbClr val="101010"/>
-                </a:solidFill>
-              </a:rPr>
-              <a:t>•  Stopped early at step 28 of 1250 to capture metrics — same shape as the ZeRO-3 timeout.</a:t>
-            </a:r>
-          </a:p>
-          <a:p>
-            <a:pPr>
-              <a:spcAft>
-                <a:spcPts val="800"/>
-              </a:spcAft>
-            </a:pPr>
-            <a:r>
-              <a:rPr sz="1700">
-                <a:solidFill>
-                  <a:srgbClr val="101010"/>
-                </a:solidFill>
-              </a:rPr>
-              <a:t>•  Wall time observed: 39 min. Each step took about 80 seconds.</a:t>
-            </a:r>
-          </a:p>
-          <a:p>
-            <a:pPr lvl="1">
-              <a:spcAft>
-                <a:spcPts val="400"/>
-              </a:spcAft>
-            </a:pPr>
-            <a:r>
-              <a:rPr sz="1400">
-                <a:solidFill>
-                  <a:srgbClr val="555555"/>
-                </a:solidFill>
-              </a:rPr>
-              <a:t>    –  Projected full run: 27.9 hours. Slower than ZeRO-3.</a:t>
-            </a:r>
-          </a:p>
-          <a:p>
-            <a:pPr>
-              <a:spcAft>
-                <a:spcPts val="800"/>
-              </a:spcAft>
-            </a:pPr>
-            <a:r>
-              <a:rPr sz="1700">
-                <a:solidFill>
-                  <a:srgbClr val="101010"/>
-                </a:solidFill>
-              </a:rPr>
-              <a:t>•  Throughput: 0.095 samples/sec — about 22× slower than DDP, ~1.7× slower than ZeRO-3.</a:t>
-            </a:r>
-          </a:p>
-          <a:p>
-            <a:pPr>
-              <a:spcAft>
-                <a:spcPts val="800"/>
-              </a:spcAft>
-            </a:pPr>
-            <a:r>
-              <a:rPr sz="1700">
-                <a:solidFill>
-                  <a:srgbClr val="101010"/>
-                </a:solidFill>
-              </a:rPr>
-              <a:t>•  Peak GPU memory: 32.3 GiB. Right at the card's limit.</a:t>
-            </a:r>
-          </a:p>
-          <a:p>
-            <a:pPr lvl="1">
-              <a:spcAft>
-                <a:spcPts val="400"/>
-              </a:spcAft>
-            </a:pPr>
-            <a:r>
-              <a:rPr sz="1400">
-                <a:solidFill>
-                  <a:srgbClr val="555555"/>
-                </a:solidFill>
-              </a:rPr>
-              <a:t>    –  FSDP's contiguous FlatParameter is bigger than DeepSpeed's bucket-based scheme.</a:t>
-            </a:r>
-          </a:p>
-          <a:p>
-            <a:pPr>
-              <a:spcAft>
-                <a:spcPts val="800"/>
-              </a:spcAft>
-            </a:pPr>
-            <a:r>
-              <a:rPr sz="1700">
-                <a:solidFill>
-                  <a:srgbClr val="101010"/>
-                </a:solidFill>
-              </a:rPr>
-              <a:t>•  GPU utilization: 97.5%.</a:t>
-            </a:r>
-          </a:p>
-          <a:p>
-            <a:pPr>
-              <a:spcAft>
-                <a:spcPts val="800"/>
-              </a:spcAft>
-            </a:pPr>
-            <a:r>
-              <a:rPr sz="1700">
-                <a:solidFill>
-                  <a:srgbClr val="101010"/>
-                </a:solidFill>
-              </a:rPr>
-              <a:t>•  Why slower than ZeRO-3 on the same hardware?</a:t>
-            </a:r>
-          </a:p>
-          <a:p>
-            <a:pPr lvl="1">
-              <a:spcAft>
-                <a:spcPts val="400"/>
-              </a:spcAft>
-            </a:pPr>
-            <a:r>
-              <a:rPr sz="1400">
-                <a:solidFill>
-                  <a:srgbClr val="555555"/>
-                </a:solidFill>
-              </a:rPr>
-              <a:t>    –  DeepSpeed's bounded async config (50 MB buckets) overlaps comm with compute aggressively.</a:t>
-            </a:r>
-          </a:p>
-          <a:p>
-            <a:pPr lvl="1">
-              <a:spcAft>
-                <a:spcPts val="400"/>
-              </a:spcAft>
-            </a:pPr>
-            <a:r>
-              <a:rPr sz="1400">
-                <a:solidFill>
-                  <a:srgbClr val="555555"/>
-                </a:solidFill>
-              </a:rPr>
-              <a:t>    –  FSDP's defaults wait for each transformer block's AllGather to finish before computing.</a:t>
-            </a:r>
-          </a:p>
-          <a:p>
-            <a:pPr lvl="1">
-              <a:spcAft>
-                <a:spcPts val="400"/>
-              </a:spcAft>
-            </a:pPr>
-            <a:r>
-              <a:rPr sz="1400">
-                <a:solidFill>
-                  <a:srgbClr val="555555"/>
-                </a:solidFill>
-              </a:rPr>
-              <a:t>    –  Same algorithm, different async behavior — the difference is real on a slow link.</a:t>
-            </a:r>
-          </a:p>
-        </p:txBody>
-      </p:sp>
-      <p:pic>
-        <p:nvPicPr>
-          <p:cNvPr id="4" name="Picture 3" descr="gpu_utilization_curve.png"/>
-          <p:cNvPicPr>
-            <a:picLocks noChangeAspect="1"/>
-          </p:cNvPicPr>
-          <p:nvPr/>
-        </p:nvPicPr>
-        <p:blipFill>
-          <a:blip r:embed="rId2"/>
-          <a:stretch>
-            <a:fillRect/>
-          </a:stretch>
-        </p:blipFill>
-        <p:spPr>
-          <a:xfrm>
-            <a:off x="6766560" y="1828800"/>
-            <a:ext cx="4937760" cy="3086100"/>
-          </a:xfrm>
-          <a:prstGeom prst="rect">
-            <a:avLst/>
-          </a:prstGeom>
-        </p:spPr>
-      </p:pic>
+            <a:pPr algn="ctr"/>
+            <a:r>
+              <a:rPr sz="5400" b="0">
+                <a:solidFill>
+                  <a:srgbClr val="101010"/>
+                </a:solidFill>
+              </a:rPr>
+              <a:t>Tensor Parallelism</a:t>
+            </a:r>
+          </a:p>
+        </p:txBody>
+      </p:sp>
     </p:spTree>
   </p:cSld>
   <p:clrMapOvr>
@@ -5626,8 +5378,8 @@
         </p:nvSpPr>
         <p:spPr>
           <a:xfrm>
-            <a:off x="548640" y="2834640"/>
-            <a:ext cx="11064240" cy="1280160"/>
+            <a:off x="548640" y="365760"/>
+            <a:ext cx="11064240" cy="822960"/>
           </a:xfrm>
           <a:prstGeom prst="rect">
             <a:avLst/>
@@ -5640,14 +5392,157 @@
           </a:bodyPr>
           <a:lstStyle/>
           <a:p>
-            <a:pPr algn="ctr"/>
-            <a:r>
-              <a:rPr sz="5400" b="0">
-                <a:solidFill>
-                  <a:srgbClr val="101010"/>
-                </a:solidFill>
-              </a:rPr>
-              <a:t>Putting it all together</a:t>
+            <a:pPr algn="l"/>
+            <a:r>
+              <a:rPr sz="3400" b="1">
+                <a:solidFill>
+                  <a:srgbClr val="101010"/>
+                </a:solidFill>
+              </a:rPr>
+              <a:t>Tensor Parallel: split the matmuls (Rassul)</a:t>
+            </a:r>
+          </a:p>
+        </p:txBody>
+      </p:sp>
+      <p:sp>
+        <p:nvSpPr>
+          <p:cNvPr id="3" name="TextBox 2"/>
+          <p:cNvSpPr txBox="1"/>
+          <p:nvPr/>
+        </p:nvSpPr>
+        <p:spPr>
+          <a:xfrm>
+            <a:off x="548640" y="1371600"/>
+            <a:ext cx="11064240" cy="5120640"/>
+          </a:xfrm>
+          <a:prstGeom prst="rect">
+            <a:avLst/>
+          </a:prstGeom>
+          <a:noFill/>
+        </p:spPr>
+        <p:txBody>
+          <a:bodyPr wrap="square" anchor="ctr">
+            <a:spAutoFit/>
+          </a:bodyPr>
+          <a:lstStyle/>
+          <a:p>
+            <a:pPr>
+              <a:spcAft>
+                <a:spcPts val="800"/>
+              </a:spcAft>
+            </a:pPr>
+            <a:r>
+              <a:rPr sz="1800">
+                <a:solidFill>
+                  <a:srgbClr val="101010"/>
+                </a:solidFill>
+              </a:rPr>
+              <a:t>•  Megatron-style intra-layer model parallelism. Each LlamaDecoderLayer's linear sublayers are sharded column-wise or row-wise across the two ranks.</a:t>
+            </a:r>
+          </a:p>
+          <a:p>
+            <a:pPr>
+              <a:spcAft>
+                <a:spcPts val="800"/>
+              </a:spcAft>
+            </a:pPr>
+            <a:r>
+              <a:rPr sz="1800">
+                <a:solidFill>
+                  <a:srgbClr val="101010"/>
+                </a:solidFill>
+              </a:rPr>
+              <a:t>•  Sharding plan, applied per layer via torch.distributed.tensor.parallel.parallelize_module:</a:t>
+            </a:r>
+          </a:p>
+          <a:p>
+            <a:pPr lvl="1">
+              <a:spcAft>
+                <a:spcPts val="400"/>
+              </a:spcAft>
+            </a:pPr>
+            <a:r>
+              <a:rPr sz="1500">
+                <a:solidFill>
+                  <a:srgbClr val="555555"/>
+                </a:solidFill>
+              </a:rPr>
+              <a:t>    –  q_proj, k_proj, v_proj, gate_proj, up_proj — Colwise (output dim split).</a:t>
+            </a:r>
+          </a:p>
+          <a:p>
+            <a:pPr lvl="1">
+              <a:spcAft>
+                <a:spcPts val="400"/>
+              </a:spcAft>
+            </a:pPr>
+            <a:r>
+              <a:rPr sz="1500">
+                <a:solidFill>
+                  <a:srgbClr val="555555"/>
+                </a:solidFill>
+              </a:rPr>
+              <a:t>    –  o_proj, down_proj — Rowwise (input dim split, AllReduce on output).</a:t>
+            </a:r>
+          </a:p>
+          <a:p>
+            <a:pPr lvl="1">
+              <a:spcAft>
+                <a:spcPts val="400"/>
+              </a:spcAft>
+            </a:pPr>
+            <a:r>
+              <a:rPr sz="1500">
+                <a:solidFill>
+                  <a:srgbClr val="555555"/>
+                </a:solidFill>
+              </a:rPr>
+              <a:t>    –  After parallelize, num_heads / num_key_value_heads / hidden_size are halved per rank.</a:t>
+            </a:r>
+          </a:p>
+          <a:p>
+            <a:pPr>
+              <a:spcAft>
+                <a:spcPts val="800"/>
+              </a:spcAft>
+            </a:pPr>
+            <a:r>
+              <a:rPr sz="1800">
+                <a:solidFill>
+                  <a:srgbClr val="101010"/>
+                </a:solidFill>
+              </a:rPr>
+              <a:t>•  Per-step communication: ~6 cross-node AllReduces per layer × 32 layers × 2 (fwd+bwd) ≈ 384 collectives per microbatch, × 4 grad-accum.</a:t>
+            </a:r>
+          </a:p>
+          <a:p>
+            <a:pPr>
+              <a:spcAft>
+                <a:spcPts val="800"/>
+              </a:spcAft>
+            </a:pPr>
+            <a:r>
+              <a:rPr sz="1800">
+                <a:solidFill>
+                  <a:srgbClr val="101010"/>
+                </a:solidFill>
+              </a:rPr>
+              <a:t>•  We trained the MLP projection only — LoRA on TP-sharded base linears is fragile in PyTorch 2.1.2 (DTensor + LoRA's lora_A/B reshape don't compose cleanly).</a:t>
+            </a:r>
+          </a:p>
+          <a:p>
+            <a:pPr>
+              <a:spcAft>
+                <a:spcPts val="800"/>
+              </a:spcAft>
+            </a:pPr>
+            <a:r>
+              <a:rPr sz="1800">
+                <a:solidFill>
+                  <a:srgbClr val="101010"/>
+                </a:solidFill>
+              </a:rPr>
+              <a:t>•  Custom 2-rank torchrun launcher: LLaVA/llava/train/train_tp_dist.py + scripts/run_stage2_tp.sh.</a:t>
             </a:r>
           </a:p>
         </p:txBody>
@@ -5699,7 +5594,7 @@
                   <a:srgbClr val="101010"/>
                 </a:solidFill>
               </a:rPr>
-              <a:t>Throughput by method</a:t>
+              <a:t>TP — results</a:t>
             </a:r>
           </a:p>
         </p:txBody>
@@ -5712,8 +5607,8 @@
         </p:nvSpPr>
         <p:spPr>
           <a:xfrm>
-            <a:off x="548640" y="1051560"/>
-            <a:ext cx="11064240" cy="365760"/>
+            <a:off x="548640" y="1371600"/>
+            <a:ext cx="5852160" cy="5120640"/>
           </a:xfrm>
           <a:prstGeom prst="rect">
             <a:avLst/>
@@ -5721,25 +5616,120 @@
           <a:noFill/>
         </p:spPr>
         <p:txBody>
-          <a:bodyPr wrap="none">
+          <a:bodyPr wrap="square" anchor="ctr">
             <a:spAutoFit/>
           </a:bodyPr>
           <a:lstStyle/>
           <a:p>
-            <a:r>
-              <a:rPr sz="1800" i="1">
+            <a:pPr>
+              <a:spcAft>
+                <a:spcPts val="800"/>
+              </a:spcAft>
+            </a:pPr>
+            <a:r>
+              <a:rPr sz="1800">
+                <a:solidFill>
+                  <a:srgbClr val="101010"/>
+                </a:solidFill>
+              </a:rPr>
+              <a:t>•  Ran a full epoch — 1250 steps × effective batch 8 — at 11 s/step.</a:t>
+            </a:r>
+          </a:p>
+          <a:p>
+            <a:pPr>
+              <a:spcAft>
+                <a:spcPts val="800"/>
+              </a:spcAft>
+            </a:pPr>
+            <a:r>
+              <a:rPr sz="1800">
+                <a:solidFill>
+                  <a:srgbClr val="101010"/>
+                </a:solidFill>
+              </a:rPr>
+              <a:t>•  Wall time: 3.85 h. Throughput: 0.72 sps — 0.32× DDP, but 4× faster than ZeRO-3 and 8× faster than FSDP.</a:t>
+            </a:r>
+          </a:p>
+          <a:p>
+            <a:pPr lvl="1">
+              <a:spcAft>
+                <a:spcPts val="400"/>
+              </a:spcAft>
+            </a:pPr>
+            <a:r>
+              <a:rPr sz="1500">
                 <a:solidFill>
                   <a:srgbClr val="555555"/>
                 </a:solidFill>
               </a:rPr>
-              <a:t>ZeRO-2 wins. ZeRO-3 and FSDP collapse on the cross-node link.</a:t>
+              <a:t>    –  TP ships ~2 GB of activations per microbatch vs ZeRO-3's ~14 GB of weights — order of magnitude less.</a:t>
+            </a:r>
+          </a:p>
+          <a:p>
+            <a:pPr>
+              <a:spcAft>
+                <a:spcPts val="800"/>
+              </a:spcAft>
+            </a:pPr>
+            <a:r>
+              <a:rPr sz="1800">
+                <a:solidFill>
+                  <a:srgbClr val="101010"/>
+                </a:solidFill>
+              </a:rPr>
+              <a:t>•  Peak GPU memory: 30.6 GiB. GPU util: 77.7%. Final loss: 1.03 — matches DDP at full epoch.</a:t>
+            </a:r>
+          </a:p>
+          <a:p>
+            <a:pPr>
+              <a:spcAft>
+                <a:spcPts val="800"/>
+              </a:spcAft>
+            </a:pPr>
+            <a:r>
+              <a:rPr sz="1800">
+                <a:solidFill>
+                  <a:srgbClr val="101010"/>
+                </a:solidFill>
+              </a:rPr>
+              <a:t>•  Takeaway: TP is the only model-parallel method actually usable on this link.</a:t>
+            </a:r>
+          </a:p>
+          <a:p>
+            <a:pPr lvl="1">
+              <a:spcAft>
+                <a:spcPts val="400"/>
+              </a:spcAft>
+            </a:pPr>
+            <a:r>
+              <a:rPr sz="1500">
+                <a:solidFill>
+                  <a:srgbClr val="555555"/>
+                </a:solidFill>
+              </a:rPr>
+              <a:t>    –  Still 3× slower than DDP — per-layer collectives accumulate Ethernet latency.</a:t>
+            </a:r>
+          </a:p>
+          <a:p>
+            <a:pPr lvl="1">
+              <a:spcAft>
+                <a:spcPts val="400"/>
+              </a:spcAft>
+            </a:pPr>
+            <a:r>
+              <a:rPr sz="1500">
+                <a:solidFill>
+                  <a:srgbClr val="555555"/>
+                </a:solidFill>
+              </a:rPr>
+              <a:t>    –  Designed for NVLink, where AllReduce is essentially free.</a:t>
             </a:r>
           </a:p>
         </p:txBody>
       </p:sp>
       <p:pic>
         <p:nvPicPr>
-          <p:cNvPr id="4" name="Picture 3" descr="1_throughput.png"/>
+          <p:cNvPr id="4" name="Picture 3" descr="gpu_utilization_curve.png"/>
           <p:cNvPicPr>
             <a:picLocks noChangeAspect="1"/>
           </p:cNvPicPr>
@@ -5753,8 +5743,8 @@
         </p:blipFill>
         <p:spPr>
           <a:xfrm>
-            <a:off x="2208276" y="1371600"/>
-            <a:ext cx="7772400" cy="5181600"/>
+            <a:off x="6766560" y="1828800"/>
+            <a:ext cx="4937760" cy="3086100"/>
           </a:xfrm>
           <a:prstGeom prst="rect">
             <a:avLst/>
@@ -5787,8 +5777,8 @@
         </p:nvSpPr>
         <p:spPr>
           <a:xfrm>
-            <a:off x="548640" y="365760"/>
-            <a:ext cx="11064240" cy="822960"/>
+            <a:off x="548640" y="2834640"/>
+            <a:ext cx="11064240" cy="1280160"/>
           </a:xfrm>
           <a:prstGeom prst="rect">
             <a:avLst/>
@@ -5801,75 +5791,18 @@
           </a:bodyPr>
           <a:lstStyle/>
           <a:p>
-            <a:pPr algn="l"/>
-            <a:r>
-              <a:rPr sz="3400" b="1">
-                <a:solidFill>
-                  <a:srgbClr val="101010"/>
-                </a:solidFill>
-              </a:rPr>
-              <a:t>Speedup vs DDP</a:t>
-            </a:r>
-          </a:p>
-        </p:txBody>
-      </p:sp>
-      <p:sp>
-        <p:nvSpPr>
-          <p:cNvPr id="3" name="TextBox 2"/>
-          <p:cNvSpPr txBox="1"/>
-          <p:nvPr/>
-        </p:nvSpPr>
-        <p:spPr>
-          <a:xfrm>
-            <a:off x="548640" y="1051560"/>
-            <a:ext cx="11064240" cy="365760"/>
-          </a:xfrm>
-          <a:prstGeom prst="rect">
-            <a:avLst/>
-          </a:prstGeom>
-          <a:noFill/>
-        </p:spPr>
-        <p:txBody>
-          <a:bodyPr wrap="none">
-            <a:spAutoFit/>
-          </a:bodyPr>
-          <a:lstStyle/>
-          <a:p>
-            <a:r>
-              <a:rPr sz="1800" i="1">
-                <a:solidFill>
-                  <a:srgbClr val="555555"/>
-                </a:solidFill>
-              </a:rPr>
-              <a:t>Only ZeRO-2 actually beats the naïve baseline.</a:t>
-            </a:r>
-          </a:p>
-        </p:txBody>
-      </p:sp>
-      <p:pic>
-        <p:nvPicPr>
-          <p:cNvPr id="4" name="Picture 3" descr="3_speedup_vs_ddp.png"/>
-          <p:cNvPicPr>
-            <a:picLocks noChangeAspect="1"/>
-          </p:cNvPicPr>
-          <p:nvPr/>
-        </p:nvPicPr>
-        <p:blipFill>
-          <a:blip r:embed="rId2"/>
-          <a:stretch>
-            <a:fillRect/>
-          </a:stretch>
-        </p:blipFill>
-        <p:spPr>
-          <a:xfrm>
-            <a:off x="2208276" y="1371600"/>
-            <a:ext cx="7772400" cy="5181600"/>
-          </a:xfrm>
-          <a:prstGeom prst="rect">
-            <a:avLst/>
-          </a:prstGeom>
-        </p:spPr>
-      </p:pic>
+            <a:pPr algn="ctr"/>
+            <a:r>
+              <a:rPr sz="5400" b="0">
+                <a:solidFill>
+                  <a:srgbClr val="101010"/>
+                </a:solidFill>
+              </a:rPr>
+              <a:t>Putting it all together</a:t>
+            </a:r>
+          </a:p>
+        </p:txBody>
+      </p:sp>
     </p:spTree>
   </p:cSld>
   <p:clrMapOvr>
@@ -5917,7 +5850,7 @@
                   <a:srgbClr val="101010"/>
                 </a:solidFill>
               </a:rPr>
-              <a:t>Peak GPU memory</a:t>
+              <a:t>Throughput by method</a:t>
             </a:r>
           </a:p>
         </p:txBody>
@@ -5931,7 +5864,7 @@
         <p:spPr>
           <a:xfrm>
             <a:off x="548640" y="1051560"/>
-            <a:ext cx="11064240" cy="365760"/>
+            <a:ext cx="11064240" cy="685800"/>
           </a:xfrm>
           <a:prstGeom prst="rect">
             <a:avLst/>
@@ -5939,25 +5872,25 @@
           <a:noFill/>
         </p:spPr>
         <p:txBody>
-          <a:bodyPr wrap="none">
+          <a:bodyPr wrap="square">
             <a:spAutoFit/>
           </a:bodyPr>
           <a:lstStyle/>
           <a:p>
             <a:r>
-              <a:rPr sz="1800" i="1">
+              <a:rPr sz="1600" i="1">
                 <a:solidFill>
                   <a:srgbClr val="555555"/>
                 </a:solidFill>
               </a:rPr>
-              <a:t>ZeRO-3 shards the most, FSDP saturates the card. ZeRO-2 hits a sweet spot.</a:t>
+              <a:t>ZeRO-2 wins, ZeRO-1 close behind. ZeRO-3 / FSDP collapse on Ethernet; TP in the middle.</a:t>
             </a:r>
           </a:p>
         </p:txBody>
       </p:sp>
       <p:pic>
         <p:nvPicPr>
-          <p:cNvPr id="4" name="Picture 3" descr="4_gpu_memory.png"/>
+          <p:cNvPr id="4" name="Picture 3" descr="1_throughput.png"/>
           <p:cNvPicPr>
             <a:picLocks noChangeAspect="1"/>
           </p:cNvPicPr>
@@ -5971,7 +5904,7 @@
         </p:blipFill>
         <p:spPr>
           <a:xfrm>
-            <a:off x="2208276" y="1371600"/>
+            <a:off x="2208276" y="1737360"/>
             <a:ext cx="7772400" cy="5181600"/>
           </a:xfrm>
           <a:prstGeom prst="rect">
@@ -6026,7 +5959,7 @@
                   <a:srgbClr val="101010"/>
                 </a:solidFill>
               </a:rPr>
-              <a:t>Goodput — loss reduction per second</a:t>
+              <a:t>Peak GPU memory</a:t>
             </a:r>
           </a:p>
         </p:txBody>
@@ -6040,7 +5973,7 @@
         <p:spPr>
           <a:xfrm>
             <a:off x="548640" y="1051560"/>
-            <a:ext cx="11064240" cy="365760"/>
+            <a:ext cx="11064240" cy="685800"/>
           </a:xfrm>
           <a:prstGeom prst="rect">
             <a:avLst/>
@@ -6048,25 +5981,25 @@
           <a:noFill/>
         </p:spPr>
         <p:txBody>
-          <a:bodyPr wrap="none">
+          <a:bodyPr wrap="square">
             <a:spAutoFit/>
           </a:bodyPr>
           <a:lstStyle/>
           <a:p>
             <a:r>
-              <a:rPr sz="1800" i="1">
+              <a:rPr sz="1600" i="1">
                 <a:solidFill>
                   <a:srgbClr val="555555"/>
                 </a:solidFill>
               </a:rPr>
-              <a:t>What you get back from each second of GPU time.</a:t>
+              <a:t>ZeRO-3 shards the most. FSDP and TP saturate the card. ZeRO-2 hits a sweet spot.</a:t>
             </a:r>
           </a:p>
         </p:txBody>
       </p:sp>
       <p:pic>
         <p:nvPicPr>
-          <p:cNvPr id="4" name="Picture 3" descr="9a_goodput_per_sec.png"/>
+          <p:cNvPr id="4" name="Picture 3" descr="4_gpu_memory.png"/>
           <p:cNvPicPr>
             <a:picLocks noChangeAspect="1"/>
           </p:cNvPicPr>
@@ -6080,7 +6013,7 @@
         </p:blipFill>
         <p:spPr>
           <a:xfrm>
-            <a:off x="2208276" y="1371600"/>
+            <a:off x="2208276" y="1737360"/>
             <a:ext cx="7772400" cy="5181600"/>
           </a:xfrm>
           <a:prstGeom prst="rect">
@@ -6135,7 +6068,7 @@
                   <a:srgbClr val="101010"/>
                 </a:solidFill>
               </a:rPr>
-              <a:t>Statistical efficiency</a:t>
+              <a:t>Goodput — loss reduction per second</a:t>
             </a:r>
           </a:p>
         </p:txBody>
@@ -6149,7 +6082,7 @@
         <p:spPr>
           <a:xfrm>
             <a:off x="548640" y="1051560"/>
-            <a:ext cx="11064240" cy="365760"/>
+            <a:ext cx="11064240" cy="685800"/>
           </a:xfrm>
           <a:prstGeom prst="rect">
             <a:avLst/>
@@ -6157,25 +6090,25 @@
           <a:noFill/>
         </p:spPr>
         <p:txBody>
-          <a:bodyPr wrap="none">
+          <a:bodyPr wrap="square">
             <a:spAutoFit/>
           </a:bodyPr>
           <a:lstStyle/>
           <a:p>
             <a:r>
-              <a:rPr sz="1800" i="1">
+              <a:rPr sz="1600" i="1">
                 <a:solidFill>
                   <a:srgbClr val="555555"/>
                 </a:solidFill>
               </a:rPr>
-              <a:t>Loss reduction per training sample. Larger effective batches converge faster per sample.</a:t>
+              <a:t>Full-epoch methods cluster on top; cross-layer-comm methods (ZeRO-3 / FSDP / TP) sit below, ordered by throughput.</a:t>
             </a:r>
           </a:p>
         </p:txBody>
       </p:sp>
       <p:pic>
         <p:nvPicPr>
-          <p:cNvPr id="4" name="Picture 3" descr="9b_goodput_per_sample.png"/>
+          <p:cNvPr id="4" name="Picture 3" descr="9a_goodput_per_sec.png"/>
           <p:cNvPicPr>
             <a:picLocks noChangeAspect="1"/>
           </p:cNvPicPr>
@@ -6189,7 +6122,7 @@
         </p:blipFill>
         <p:spPr>
           <a:xfrm>
-            <a:off x="2208276" y="1371600"/>
+            <a:off x="2208276" y="1737360"/>
             <a:ext cx="7772400" cy="5181600"/>
           </a:xfrm>
           <a:prstGeom prst="rect">
@@ -6258,7 +6191,7 @@
         <p:spPr>
           <a:xfrm>
             <a:off x="548640" y="1051560"/>
-            <a:ext cx="11064240" cy="365760"/>
+            <a:ext cx="11064240" cy="685800"/>
           </a:xfrm>
           <a:prstGeom prst="rect">
             <a:avLst/>
@@ -6266,18 +6199,18 @@
           <a:noFill/>
         </p:spPr>
         <p:txBody>
-          <a:bodyPr wrap="none">
+          <a:bodyPr wrap="square">
             <a:spAutoFit/>
           </a:bodyPr>
           <a:lstStyle/>
           <a:p>
             <a:r>
-              <a:rPr sz="1800" i="1">
+              <a:rPr sz="1600" i="1">
                 <a:solidFill>
                   <a:srgbClr val="555555"/>
                 </a:solidFill>
               </a:rPr>
-              <a:t>Methods that completed all reach a similar loss. The gap is wall-clock, not statistical.</a:t>
+              <a:t>All methods follow the same loss-vs-step curve at matched batch. TP's curve extends further because its smaller batch (8 vs 32) needs 1250 steps for a full epoch.</a:t>
             </a:r>
           </a:p>
         </p:txBody>
@@ -6298,7 +6231,7 @@
         </p:blipFill>
         <p:spPr>
           <a:xfrm>
-            <a:off x="1979676" y="1371600"/>
+            <a:off x="1979676" y="1737360"/>
             <a:ext cx="8229600" cy="4572000"/>
           </a:xfrm>
           <a:prstGeom prst="rect">
@@ -6386,12 +6319,42 @@
               </a:spcAft>
             </a:pPr>
             <a:r>
-              <a:rPr sz="2100">
-                <a:solidFill>
-                  <a:srgbClr val="101010"/>
-                </a:solidFill>
-              </a:rPr>
-              <a:t>•  ZeRO-2 is the right tool for LoRA fine-tuning on slow interconnects.</a:t>
+              <a:rPr sz="2200">
+                <a:solidFill>
+                  <a:srgbClr val="101010"/>
+                </a:solidFill>
+              </a:rPr>
+              <a:t>•  ZeRO-2 wins for LoRA on slow interconnects (1.28× DDP). ZeRO-1 is close behind at 1.15×.</a:t>
+            </a:r>
+          </a:p>
+          <a:p>
+            <a:pPr>
+              <a:spcAft>
+                <a:spcPts val="800"/>
+              </a:spcAft>
+            </a:pPr>
+            <a:r>
+              <a:rPr sz="2200">
+                <a:solidFill>
+                  <a:srgbClr val="101010"/>
+                </a:solidFill>
+              </a:rPr>
+              <a:t>•  Pipeline parallelism made the model fit but not faster — Gloo cross-node transfers cost more than DDP's single AllReduce.</a:t>
+            </a:r>
+          </a:p>
+          <a:p>
+            <a:pPr>
+              <a:spcAft>
+                <a:spcPts val="800"/>
+              </a:spcAft>
+            </a:pPr>
+            <a:r>
+              <a:rPr sz="2200">
+                <a:solidFill>
+                  <a:srgbClr val="101010"/>
+                </a:solidFill>
+              </a:rPr>
+              <a:t>•  ZeRO-3 and FSDP fall apart over 1 Gbps Ethernet — per-layer AllGather of bf16 weights is intractable.</a:t>
             </a:r>
           </a:p>
           <a:p>
@@ -6401,132 +6364,57 @@
               </a:spcAft>
             </a:pPr>
             <a:r>
-              <a:rPr sz="1800">
+              <a:rPr sz="1900">
                 <a:solidFill>
                   <a:srgbClr val="555555"/>
                 </a:solidFill>
               </a:rPr>
-              <a:t>    –  Sharding optimizer + grads is enough. DeepSpeed's overlap quietly does the rest.</a:t>
-            </a:r>
-          </a:p>
-          <a:p>
-            <a:pPr>
-              <a:spcAft>
-                <a:spcPts val="800"/>
-              </a:spcAft>
-            </a:pPr>
-            <a:r>
-              <a:rPr sz="2100">
-                <a:solidFill>
-                  <a:srgbClr val="101010"/>
-                </a:solidFill>
-              </a:rPr>
-              <a:t>•  Pipeline parallelism made the model fit but not faster.</a:t>
-            </a:r>
-          </a:p>
-          <a:p>
-            <a:pPr lvl="1">
-              <a:spcAft>
-                <a:spcPts val="400"/>
-              </a:spcAft>
-            </a:pPr>
-            <a:r>
-              <a:rPr sz="1800">
-                <a:solidFill>
-                  <a:srgbClr val="555555"/>
-                </a:solidFill>
-              </a:rPr>
-              <a:t>    –  Cross-node Gloo activation transfers are slower than DDP's single AllReduce.</a:t>
-            </a:r>
-          </a:p>
-          <a:p>
-            <a:pPr lvl="1">
-              <a:spcAft>
-                <a:spcPts val="400"/>
-              </a:spcAft>
-            </a:pPr>
-            <a:r>
-              <a:rPr sz="1800">
-                <a:solidFill>
-                  <a:srgbClr val="555555"/>
-                </a:solidFill>
-              </a:rPr>
-              <a:t>    –  Layer count is a poor proxy for memory cost — the vision tower and LM head dominate.</a:t>
-            </a:r>
-          </a:p>
-          <a:p>
-            <a:pPr>
-              <a:spcAft>
-                <a:spcPts val="800"/>
-              </a:spcAft>
-            </a:pPr>
-            <a:r>
-              <a:rPr sz="2100">
-                <a:solidFill>
-                  <a:srgbClr val="101010"/>
-                </a:solidFill>
-              </a:rPr>
-              <a:t>•  ZeRO-3 and FSDP fall apart over Ethernet.</a:t>
-            </a:r>
-          </a:p>
-          <a:p>
-            <a:pPr lvl="1">
-              <a:spcAft>
-                <a:spcPts val="400"/>
-              </a:spcAft>
-            </a:pPr>
-            <a:r>
-              <a:rPr sz="1800">
-                <a:solidFill>
-                  <a:srgbClr val="555555"/>
-                </a:solidFill>
-              </a:rPr>
-              <a:t>    –  Per-layer AllGather of full bf16 weights is intractable on 1 Gbps.</a:t>
-            </a:r>
-          </a:p>
-          <a:p>
-            <a:pPr lvl="1">
-              <a:spcAft>
-                <a:spcPts val="400"/>
-              </a:spcAft>
-            </a:pPr>
-            <a:r>
-              <a:rPr sz="1800">
-                <a:solidFill>
-                  <a:srgbClr val="555555"/>
-                </a:solidFill>
-              </a:rPr>
-              <a:t>    –  Implementation matters — DeepSpeed ZeRO-3 is ~1.7× faster than PyTorch FSDP because of better overlap.</a:t>
-            </a:r>
-          </a:p>
-          <a:p>
-            <a:pPr>
-              <a:spcAft>
-                <a:spcPts val="800"/>
-              </a:spcAft>
-            </a:pPr>
-            <a:r>
-              <a:rPr sz="2100">
-                <a:solidFill>
-                  <a:srgbClr val="101010"/>
-                </a:solidFill>
-              </a:rPr>
-              <a:t>•  These methods would scale on InfiniBand or NVLink. Wrong tool for this hardware.</a:t>
-            </a:r>
-          </a:p>
-          <a:p>
-            <a:pPr>
-              <a:spcAft>
-                <a:spcPts val="800"/>
-              </a:spcAft>
-            </a:pPr>
-            <a:r>
-              <a:rPr sz="2100">
-                <a:solidFill>
-                  <a:srgbClr val="101010"/>
-                </a:solidFill>
-              </a:rPr>
-              <a:t>•  A 7B model with LoRA fits comfortably on a single 32 GiB card. Pick a data-parallel variant.</a:t>
+              <a:t>    –  Implementation matters: DeepSpeed ZeRO-3 is ~1.7× faster than PyTorch FSDP, thanks to better overlap.</a:t>
+            </a:r>
+          </a:p>
+          <a:p>
+            <a:pPr>
+              <a:spcAft>
+                <a:spcPts val="800"/>
+              </a:spcAft>
+            </a:pPr>
+            <a:r>
+              <a:rPr sz="2200">
+                <a:solidFill>
+                  <a:srgbClr val="101010"/>
+                </a:solidFill>
+              </a:rPr>
+              <a:t>•  Tensor Parallel is the only model-parallel method actually usable here — 3× slower than DDP, but ships ~7× less data than ZeRO-3.</a:t>
+            </a:r>
+          </a:p>
+          <a:p>
+            <a:pPr>
+              <a:spcAft>
+                <a:spcPts val="800"/>
+              </a:spcAft>
+            </a:pPr>
+            <a:r>
+              <a:rPr sz="2200">
+                <a:solidFill>
+                  <a:srgbClr val="101010"/>
+                </a:solidFill>
+              </a:rPr>
+              <a:t>•  The heavy methods (ZeRO-3, FSDP, TP) all need NVLink or InfiniBand. Wrong tool for Ethernet.</a:t>
+            </a:r>
+          </a:p>
+          <a:p>
+            <a:pPr>
+              <a:spcAft>
+                <a:spcPts val="800"/>
+              </a:spcAft>
+            </a:pPr>
+            <a:r>
+              <a:rPr sz="2200">
+                <a:solidFill>
+                  <a:srgbClr val="101010"/>
+                </a:solidFill>
+              </a:rPr>
+              <a:t>•  A 7B model with LoRA fits comfortably on one 32 GiB card — pick a data-parallel variant.</a:t>
             </a:r>
           </a:p>
         </p:txBody>
@@ -7013,7 +6901,7 @@
                   <a:srgbClr val="555555"/>
                 </a:solidFill>
               </a:rPr>
-              <a:t>    –  DDP and ZeRO-2: 32 (per_device=16, world=2)</a:t>
+              <a:t>    –  DDP, ZeRO-1, ZeRO-2: 32 (per_device=16, world=2)</a:t>
             </a:r>
           </a:p>
           <a:p>
@@ -7043,7 +6931,22 @@
                   <a:srgbClr val="555555"/>
                 </a:solidFill>
               </a:rPr>
-              <a:t>    –  ZeRO-3 and FSDP: 8 (per_device=1, accum=4, world=2)</a:t>
+              <a:t>    –  ZeRO-3, FSDP, TP: 8 (per_device=1, accum=4, world=2)</a:t>
+            </a:r>
+          </a:p>
+          <a:p>
+            <a:pPr lvl="1">
+              <a:spcAft>
+                <a:spcPts val="400"/>
+              </a:spcAft>
+            </a:pPr>
+            <a:r>
+              <a:rPr sz="1900">
+                <a:solidFill>
+                  <a:srgbClr val="555555"/>
+                </a:solidFill>
+              </a:rPr>
+              <a:t>    –  TP trains the projection only — no LoRA, since LoRA on TP-sharded base linears is fragile in PyTorch 2.1.</a:t>
             </a:r>
           </a:p>
         </p:txBody>
@@ -7163,7 +7066,7 @@
                   <a:srgbClr val="101010"/>
                 </a:solidFill>
               </a:rPr>
-              <a:t>•  Pipeline parallelism — the model is split across the two nodes. Owned by Ghallab.</a:t>
+              <a:t>•  Pipeline parallelism — the model is split across the two nodes layer-wise. Owned by Ghallab.</a:t>
             </a:r>
           </a:p>
           <a:p>
@@ -7178,7 +7081,7 @@
                   <a:srgbClr val="101010"/>
                 </a:solidFill>
               </a:rPr>
-              <a:t>•  ZeRO-2 — data parallelism with sharded optimizer states and gradients. Owned by Omar.</a:t>
+              <a:t>•  ZeRO-1 — DDP with sharded optimizer states. Owned by Omar.</a:t>
             </a:r>
           </a:p>
           <a:p>
@@ -7193,7 +7096,7 @@
                   <a:srgbClr val="101010"/>
                 </a:solidFill>
               </a:rPr>
-              <a:t>•  ZeRO-3 — same as ZeRO-2 but parameters are also sharded. Owned by Rassul.</a:t>
+              <a:t>•  ZeRO-2 — same plus sharded gradients. Owned by Omar.</a:t>
             </a:r>
           </a:p>
           <a:p>
@@ -7208,7 +7111,37 @@
                   <a:srgbClr val="101010"/>
                 </a:solidFill>
               </a:rPr>
-              <a:t>•  PyTorch FSDP — PyTorch-native equivalent of ZeRO-3, different implementation. Owned by Rassul.</a:t>
+              <a:t>•  ZeRO-3 — same plus sharded parameters. Owned by Omar.</a:t>
+            </a:r>
+          </a:p>
+          <a:p>
+            <a:pPr>
+              <a:spcAft>
+                <a:spcPts val="800"/>
+              </a:spcAft>
+            </a:pPr>
+            <a:r>
+              <a:rPr sz="2200">
+                <a:solidFill>
+                  <a:srgbClr val="101010"/>
+                </a:solidFill>
+              </a:rPr>
+              <a:t>•  PyTorch FSDP — PyTorch-native equivalent of ZeRO-3. Owned by Rassul.</a:t>
+            </a:r>
+          </a:p>
+          <a:p>
+            <a:pPr>
+              <a:spcAft>
+                <a:spcPts val="800"/>
+              </a:spcAft>
+            </a:pPr>
+            <a:r>
+              <a:rPr sz="2200">
+                <a:solidFill>
+                  <a:srgbClr val="101010"/>
+                </a:solidFill>
+              </a:rPr>
+              <a:t>•  Tensor Parallel — splits each layer's matmuls across the two nodes. Owned by Rassul.</a:t>
             </a:r>
           </a:p>
           <a:p>
@@ -7698,8 +7631,8 @@
         </p:nvSpPr>
         <p:spPr>
           <a:xfrm>
-            <a:off x="548640" y="365760"/>
-            <a:ext cx="11064240" cy="822960"/>
+            <a:off x="548640" y="2834640"/>
+            <a:ext cx="11064240" cy="1280160"/>
           </a:xfrm>
           <a:prstGeom prst="rect">
             <a:avLst/>
@@ -7712,75 +7645,18 @@
           </a:bodyPr>
           <a:lstStyle/>
           <a:p>
-            <a:pPr algn="l"/>
-            <a:r>
-              <a:rPr sz="3400" b="1">
-                <a:solidFill>
-                  <a:srgbClr val="101010"/>
-                </a:solidFill>
-              </a:rPr>
-              <a:t>DDP — GPU utilization over time</a:t>
-            </a:r>
-          </a:p>
-        </p:txBody>
-      </p:sp>
-      <p:sp>
-        <p:nvSpPr>
-          <p:cNvPr id="3" name="TextBox 2"/>
-          <p:cNvSpPr txBox="1"/>
-          <p:nvPr/>
-        </p:nvSpPr>
-        <p:spPr>
-          <a:xfrm>
-            <a:off x="548640" y="1051560"/>
-            <a:ext cx="11064240" cy="365760"/>
-          </a:xfrm>
-          <a:prstGeom prst="rect">
-            <a:avLst/>
-          </a:prstGeom>
-          <a:noFill/>
-        </p:spPr>
-        <p:txBody>
-          <a:bodyPr wrap="none">
-            <a:spAutoFit/>
-          </a:bodyPr>
-          <a:lstStyle/>
-          <a:p>
-            <a:r>
-              <a:rPr sz="1800" i="1">
-                <a:solidFill>
-                  <a:srgbClr val="555555"/>
-                </a:solidFill>
-              </a:rPr>
-              <a:t>Sharp drops on every step are AllReduce stalls — the cost of cross-node Ethernet.</a:t>
-            </a:r>
-          </a:p>
-        </p:txBody>
-      </p:sp>
-      <p:pic>
-        <p:nvPicPr>
-          <p:cNvPr id="4" name="Picture 3" descr="gpu_utilization_curve.png"/>
-          <p:cNvPicPr>
-            <a:picLocks noChangeAspect="1"/>
-          </p:cNvPicPr>
-          <p:nvPr/>
-        </p:nvPicPr>
-        <p:blipFill>
-          <a:blip r:embed="rId2"/>
-          <a:stretch>
-            <a:fillRect/>
-          </a:stretch>
-        </p:blipFill>
-        <p:spPr>
-          <a:xfrm>
-            <a:off x="1979676" y="1371600"/>
-            <a:ext cx="8229600" cy="5143500"/>
-          </a:xfrm>
-          <a:prstGeom prst="rect">
-            <a:avLst/>
-          </a:prstGeom>
-        </p:spPr>
-      </p:pic>
+            <a:pPr algn="ctr"/>
+            <a:r>
+              <a:rPr sz="5400" b="0">
+                <a:solidFill>
+                  <a:srgbClr val="101010"/>
+                </a:solidFill>
+              </a:rPr>
+              <a:t>Pipeline Parallelism</a:t>
+            </a:r>
+          </a:p>
+        </p:txBody>
+      </p:sp>
     </p:spTree>
   </p:cSld>
   <p:clrMapOvr>
@@ -7807,8 +7683,8 @@
         </p:nvSpPr>
         <p:spPr>
           <a:xfrm>
-            <a:off x="548640" y="2834640"/>
-            <a:ext cx="11064240" cy="1280160"/>
+            <a:off x="548640" y="365760"/>
+            <a:ext cx="11064240" cy="822960"/>
           </a:xfrm>
           <a:prstGeom prst="rect">
             <a:avLst/>
@@ -7821,14 +7697,157 @@
           </a:bodyPr>
           <a:lstStyle/>
           <a:p>
-            <a:pPr algn="ctr"/>
-            <a:r>
-              <a:rPr sz="5400" b="0">
-                <a:solidFill>
-                  <a:srgbClr val="101010"/>
-                </a:solidFill>
-              </a:rPr>
-              <a:t>Pipeline Parallelism</a:t>
+            <a:pPr algn="l"/>
+            <a:r>
+              <a:rPr sz="3400" b="1">
+                <a:solidFill>
+                  <a:srgbClr val="101010"/>
+                </a:solidFill>
+              </a:rPr>
+              <a:t>How we built it (Ghallab)</a:t>
+            </a:r>
+          </a:p>
+        </p:txBody>
+      </p:sp>
+      <p:sp>
+        <p:nvSpPr>
+          <p:cNvPr id="3" name="TextBox 2"/>
+          <p:cNvSpPr txBox="1"/>
+          <p:nvPr/>
+        </p:nvSpPr>
+        <p:spPr>
+          <a:xfrm>
+            <a:off x="548640" y="1371600"/>
+            <a:ext cx="11064240" cy="5120640"/>
+          </a:xfrm>
+          <a:prstGeom prst="rect">
+            <a:avLst/>
+          </a:prstGeom>
+          <a:noFill/>
+        </p:spPr>
+        <p:txBody>
+          <a:bodyPr wrap="square" anchor="ctr">
+            <a:spAutoFit/>
+          </a:bodyPr>
+          <a:lstStyle/>
+          <a:p>
+            <a:pPr>
+              <a:spcAft>
+                <a:spcPts val="800"/>
+              </a:spcAft>
+            </a:pPr>
+            <a:r>
+              <a:rPr sz="2200">
+                <a:solidFill>
+                  <a:srgbClr val="101010"/>
+                </a:solidFill>
+              </a:rPr>
+              <a:t>•  Manual two-stage pipeline. We didn't use torchgpipe or DeepSpeed-Pipeline.</a:t>
+            </a:r>
+          </a:p>
+          <a:p>
+            <a:pPr lvl="1">
+              <a:spcAft>
+                <a:spcPts val="400"/>
+              </a:spcAft>
+            </a:pPr>
+            <a:r>
+              <a:rPr sz="1900">
+                <a:solidFill>
+                  <a:srgbClr val="555555"/>
+                </a:solidFill>
+              </a:rPr>
+              <a:t>    –  Custom training loop: LLaVA/llava/train/train_pipe_dist.py (~520 lines).</a:t>
+            </a:r>
+          </a:p>
+          <a:p>
+            <a:pPr lvl="1">
+              <a:spcAft>
+                <a:spcPts val="400"/>
+              </a:spcAft>
+            </a:pPr>
+            <a:r>
+              <a:rPr sz="1900">
+                <a:solidFill>
+                  <a:srgbClr val="555555"/>
+                </a:solidFill>
+              </a:rPr>
+              <a:t>    –  Gloo backend for cross-node send/recv. NCCL had ordering issues with our mixed-dtype activations.</a:t>
+            </a:r>
+          </a:p>
+          <a:p>
+            <a:pPr>
+              <a:spcAft>
+                <a:spcPts val="800"/>
+              </a:spcAft>
+            </a:pPr>
+            <a:r>
+              <a:rPr sz="2200">
+                <a:solidFill>
+                  <a:srgbClr val="101010"/>
+                </a:solidFill>
+              </a:rPr>
+              <a:t>•  The model is cut at decoder layer k. There are 32 decoder layers in Vicuna-7B.</a:t>
+            </a:r>
+          </a:p>
+          <a:p>
+            <a:pPr lvl="1">
+              <a:spcAft>
+                <a:spcPts val="400"/>
+              </a:spcAft>
+            </a:pPr>
+            <a:r>
+              <a:rPr sz="1900">
+                <a:solidFill>
+                  <a:srgbClr val="555555"/>
+                </a:solidFill>
+              </a:rPr>
+              <a:t>    –  Rank 0 holds the vision tower (frozen), the MLP projection, and decoder layers 0..k-1.</a:t>
+            </a:r>
+          </a:p>
+          <a:p>
+            <a:pPr lvl="1">
+              <a:spcAft>
+                <a:spcPts val="400"/>
+              </a:spcAft>
+            </a:pPr>
+            <a:r>
+              <a:rPr sz="1900">
+                <a:solidFill>
+                  <a:srgbClr val="555555"/>
+                </a:solidFill>
+              </a:rPr>
+              <a:t>    –  Rank 1 holds layers k..31, the final norm, the LM head, and computes loss.</a:t>
+            </a:r>
+          </a:p>
+          <a:p>
+            <a:pPr lvl="1">
+              <a:spcAft>
+                <a:spcPts val="400"/>
+              </a:spcAft>
+            </a:pPr>
+            <a:r>
+              <a:rPr sz="1900">
+                <a:solidFill>
+                  <a:srgbClr val="555555"/>
+                </a:solidFill>
+              </a:rPr>
+              <a:t>    –  Activations flow forward, gradients flow back, by hand.</a:t>
+            </a:r>
+          </a:p>
+          <a:p>
+            <a:pPr>
+              <a:spcAft>
+                <a:spcPts val="800"/>
+              </a:spcAft>
+            </a:pPr>
+            <a:r>
+              <a:rPr sz="2200">
+                <a:solidFill>
+                  <a:srgbClr val="101010"/>
+                </a:solidFill>
+              </a:rPr>
+              <a:t>•  Gradient accumulation 16, microbatch 1 → effective batch 16. LoRA is added on each rank's local layers.</a:t>
             </a:r>
           </a:p>
         </p:txBody>

</xml_diff>